<commit_message>
Refine deck: fix Unilever logo, balance logo sizes, recolour, pill-based agent slide
- Fix Unilever logo: was using the white variant (invisible on light bg);
  now uses the correct blue mark, clearly visible
- Balance logo lockup: Aerchain & Infosys at equal cap-height (deck + one-pager)
- Replace teal/black Outcome & roadmap panels with a deep-violet → bright-purple
  scheme (premium, on-brand)
- Slide 3: replace text paragraphs with button/pill labels per agent, larger
  type, and add a guardrails chip strip
- Larger fonts throughout for executive readability

https://claude.ai/code/session_01H7Uxv6jiq6mA6LdW8qoYWz
</commit_message>
<xml_diff>
--- a/unilever-aerchain/Unilever_Aerchain_Infosys_Deck.pptx
+++ b/unilever-aerchain/Unilever_Aerchain_Infosys_Deck.pptx
@@ -3239,8 +3239,8 @@
         </p:blipFill>
         <p:spPr>
           <a:xfrm>
-            <a:off x="758952" y="292608"/>
-            <a:ext cx="2542032" cy="365760"/>
+            <a:off x="758952" y="256032"/>
+            <a:ext cx="2660904" cy="384048"/>
           </a:xfrm>
           <a:prstGeom prst="rect">
             <a:avLst/>
@@ -3255,8 +3255,8 @@
         </p:nvSpPr>
         <p:spPr>
           <a:xfrm>
-            <a:off x="3456432" y="0"/>
-            <a:ext cx="457200" cy="960120"/>
+            <a:off x="3474720" y="256032"/>
+            <a:ext cx="502920" cy="384048"/>
           </a:xfrm>
           <a:prstGeom prst="rect">
             <a:avLst/>
@@ -3281,7 +3281,7 @@
               </a:spcAft>
             </a:pPr>
             <a:r>
-              <a:rPr sz="1800" b="0" i="0">
+              <a:rPr sz="2000" b="0" i="0">
                 <a:solidFill>
                   <a:srgbClr val="6A707B"/>
                 </a:solidFill>
@@ -3308,23 +3308,59 @@
         </p:blipFill>
         <p:spPr>
           <a:xfrm>
-            <a:off x="3977639" y="338328"/>
-            <a:ext cx="749808" cy="292608"/>
+            <a:off x="4023360" y="256032"/>
+            <a:ext cx="1188720" cy="466344"/>
           </a:xfrm>
           <a:prstGeom prst="rect">
             <a:avLst/>
           </a:prstGeom>
         </p:spPr>
       </p:pic>
-      <p:sp>
-        <p:nvSpPr>
-          <p:cNvPr id="8" name="TextBox 7"/>
-          <p:cNvSpPr txBox="1"/>
-          <p:nvPr/>
-        </p:nvSpPr>
-        <p:spPr>
-          <a:xfrm>
-            <a:off x="5285232" y="0"/>
+      <p:cxnSp>
+        <p:nvCxnSpPr>
+          <p:cNvPr id="8" name="Connector 7"/>
+          <p:cNvCxnSpPr/>
+          <p:nvPr/>
+        </p:nvCxnSpPr>
+        <p:spPr>
+          <a:xfrm>
+            <a:off x="5468112" y="274320"/>
+            <a:ext cx="0" cy="411480"/>
+          </a:xfrm>
+          <a:prstGeom prst="bentConnector3">
+            <a:avLst/>
+          </a:prstGeom>
+          <a:ln w="9525">
+            <a:solidFill>
+              <a:srgbClr val="E2E4EA"/>
+            </a:solidFill>
+          </a:ln>
+          <a:effectLst/>
+        </p:spPr>
+        <p:style>
+          <a:lnRef idx="2">
+            <a:schemeClr val="accent1"/>
+          </a:lnRef>
+          <a:fillRef idx="0">
+            <a:schemeClr val="accent1"/>
+          </a:fillRef>
+          <a:effectRef idx="1">
+            <a:schemeClr val="accent1"/>
+          </a:effectRef>
+          <a:fontRef idx="minor">
+            <a:schemeClr val="tx1"/>
+          </a:fontRef>
+        </p:style>
+      </p:cxnSp>
+      <p:sp>
+        <p:nvSpPr>
+          <p:cNvPr id="9" name="TextBox 8"/>
+          <p:cNvSpPr txBox="1"/>
+          <p:nvPr/>
+        </p:nvSpPr>
+        <p:spPr>
+          <a:xfrm>
+            <a:off x="5687568" y="0"/>
             <a:ext cx="8229600" cy="960120"/>
           </a:xfrm>
           <a:prstGeom prst="rect">
@@ -3363,14 +3399,14 @@
       </p:sp>
       <p:sp>
         <p:nvSpPr>
-          <p:cNvPr id="9" name="TextBox 8"/>
-          <p:cNvSpPr txBox="1"/>
-          <p:nvPr/>
-        </p:nvSpPr>
-        <p:spPr>
-          <a:xfrm>
-            <a:off x="14996159" y="0"/>
-            <a:ext cx="1645920" cy="960120"/>
+          <p:cNvPr id="10" name="TextBox 9"/>
+          <p:cNvSpPr txBox="1"/>
+          <p:nvPr/>
+        </p:nvSpPr>
+        <p:spPr>
+          <a:xfrm>
+            <a:off x="14356080" y="0"/>
+            <a:ext cx="2103120" cy="960120"/>
           </a:xfrm>
           <a:prstGeom prst="rect">
             <a:avLst/>
@@ -3417,7 +3453,7 @@
       </p:sp>
       <p:pic>
         <p:nvPicPr>
-          <p:cNvPr id="10" name="Picture 9" descr="unilever_blue.png"/>
+          <p:cNvPr id="11" name="Picture 10" descr="unilever_blue.png"/>
           <p:cNvPicPr>
             <a:picLocks noChangeAspect="1"/>
           </p:cNvPicPr>
@@ -3431,8 +3467,8 @@
         </p:blipFill>
         <p:spPr>
           <a:xfrm>
-            <a:off x="16916400" y="256032"/>
-            <a:ext cx="457200" cy="475488"/>
+            <a:off x="16751808" y="155448"/>
+            <a:ext cx="594360" cy="658368"/>
           </a:xfrm>
           <a:prstGeom prst="rect">
             <a:avLst/>
@@ -3441,7 +3477,7 @@
       </p:pic>
       <p:sp>
         <p:nvSpPr>
-          <p:cNvPr id="11" name="TextBox 10"/>
+          <p:cNvPr id="12" name="TextBox 11"/>
           <p:cNvSpPr txBox="1"/>
           <p:nvPr/>
         </p:nvSpPr>
@@ -3495,7 +3531,7 @@
       </p:sp>
       <p:sp>
         <p:nvSpPr>
-          <p:cNvPr id="12" name="TextBox 11"/>
+          <p:cNvPr id="13" name="TextBox 12"/>
           <p:cNvSpPr txBox="1"/>
           <p:nvPr/>
         </p:nvSpPr>
@@ -3584,7 +3620,7 @@
       </p:sp>
       <p:sp>
         <p:nvSpPr>
-          <p:cNvPr id="13" name="TextBox 12"/>
+          <p:cNvPr id="14" name="TextBox 13"/>
           <p:cNvSpPr txBox="1"/>
           <p:nvPr/>
         </p:nvSpPr>
@@ -3629,7 +3665,7 @@
       </p:sp>
       <p:cxnSp>
         <p:nvCxnSpPr>
-          <p:cNvPr id="14" name="Connector 13"/>
+          <p:cNvPr id="15" name="Connector 14"/>
           <p:cNvCxnSpPr/>
           <p:nvPr/>
         </p:nvCxnSpPr>
@@ -3665,7 +3701,7 @@
       </p:cxnSp>
       <p:sp>
         <p:nvSpPr>
-          <p:cNvPr id="15" name="TextBox 14"/>
+          <p:cNvPr id="16" name="TextBox 15"/>
           <p:cNvSpPr txBox="1"/>
           <p:nvPr/>
         </p:nvSpPr>
@@ -3710,7 +3746,7 @@
       </p:sp>
       <p:sp>
         <p:nvSpPr>
-          <p:cNvPr id="16" name="TextBox 15"/>
+          <p:cNvPr id="17" name="TextBox 16"/>
           <p:cNvSpPr txBox="1"/>
           <p:nvPr/>
         </p:nvSpPr>
@@ -3755,7 +3791,7 @@
       </p:sp>
       <p:sp>
         <p:nvSpPr>
-          <p:cNvPr id="17" name="TextBox 16"/>
+          <p:cNvPr id="18" name="TextBox 17"/>
           <p:cNvSpPr txBox="1"/>
           <p:nvPr/>
         </p:nvSpPr>
@@ -3800,7 +3836,7 @@
       </p:sp>
       <p:sp>
         <p:nvSpPr>
-          <p:cNvPr id="18" name="TextBox 17"/>
+          <p:cNvPr id="19" name="TextBox 18"/>
           <p:cNvSpPr txBox="1"/>
           <p:nvPr/>
         </p:nvSpPr>
@@ -3845,7 +3881,7 @@
       </p:sp>
       <p:sp>
         <p:nvSpPr>
-          <p:cNvPr id="19" name="TextBox 18"/>
+          <p:cNvPr id="20" name="TextBox 19"/>
           <p:cNvSpPr txBox="1"/>
           <p:nvPr/>
         </p:nvSpPr>
@@ -3890,7 +3926,7 @@
       </p:sp>
       <p:sp>
         <p:nvSpPr>
-          <p:cNvPr id="20" name="TextBox 19"/>
+          <p:cNvPr id="21" name="TextBox 20"/>
           <p:cNvSpPr txBox="1"/>
           <p:nvPr/>
         </p:nvSpPr>
@@ -3935,7 +3971,7 @@
       </p:sp>
       <p:sp>
         <p:nvSpPr>
-          <p:cNvPr id="21" name="TextBox 20"/>
+          <p:cNvPr id="22" name="TextBox 21"/>
           <p:cNvSpPr txBox="1"/>
           <p:nvPr/>
         </p:nvSpPr>
@@ -3980,7 +4016,7 @@
       </p:sp>
       <p:sp>
         <p:nvSpPr>
-          <p:cNvPr id="22" name="TextBox 21"/>
+          <p:cNvPr id="23" name="TextBox 22"/>
           <p:cNvSpPr txBox="1"/>
           <p:nvPr/>
         </p:nvSpPr>
@@ -4025,7 +4061,7 @@
       </p:sp>
       <p:sp>
         <p:nvSpPr>
-          <p:cNvPr id="23" name="Rectangle 22"/>
+          <p:cNvPr id="24" name="Rectangle 23"/>
           <p:cNvSpPr/>
           <p:nvPr/>
         </p:nvSpPr>
@@ -4069,7 +4105,7 @@
       </p:sp>
       <p:cxnSp>
         <p:nvCxnSpPr>
-          <p:cNvPr id="24" name="Connector 23"/>
+          <p:cNvPr id="25" name="Connector 24"/>
           <p:cNvCxnSpPr/>
           <p:nvPr/>
         </p:nvCxnSpPr>
@@ -4105,7 +4141,7 @@
       </p:cxnSp>
       <p:sp>
         <p:nvSpPr>
-          <p:cNvPr id="25" name="TextBox 24"/>
+          <p:cNvPr id="26" name="TextBox 25"/>
           <p:cNvSpPr txBox="1"/>
           <p:nvPr/>
         </p:nvSpPr>
@@ -4150,7 +4186,7 @@
       </p:sp>
       <p:sp>
         <p:nvSpPr>
-          <p:cNvPr id="26" name="TextBox 25"/>
+          <p:cNvPr id="27" name="TextBox 26"/>
           <p:cNvSpPr txBox="1"/>
           <p:nvPr/>
         </p:nvSpPr>
@@ -4351,8 +4387,8 @@
         </p:blipFill>
         <p:spPr>
           <a:xfrm>
-            <a:off x="758952" y="292608"/>
-            <a:ext cx="2542032" cy="365760"/>
+            <a:off x="758952" y="256032"/>
+            <a:ext cx="2660904" cy="384048"/>
           </a:xfrm>
           <a:prstGeom prst="rect">
             <a:avLst/>
@@ -4367,8 +4403,8 @@
         </p:nvSpPr>
         <p:spPr>
           <a:xfrm>
-            <a:off x="3456432" y="0"/>
-            <a:ext cx="457200" cy="960120"/>
+            <a:off x="3474720" y="256032"/>
+            <a:ext cx="502920" cy="384048"/>
           </a:xfrm>
           <a:prstGeom prst="rect">
             <a:avLst/>
@@ -4393,7 +4429,7 @@
               </a:spcAft>
             </a:pPr>
             <a:r>
-              <a:rPr sz="1800" b="0" i="0">
+              <a:rPr sz="2000" b="0" i="0">
                 <a:solidFill>
                   <a:srgbClr val="6A707B"/>
                 </a:solidFill>
@@ -4420,8 +4456,8 @@
         </p:blipFill>
         <p:spPr>
           <a:xfrm>
-            <a:off x="3977639" y="338328"/>
-            <a:ext cx="749808" cy="292608"/>
+            <a:off x="4023360" y="256032"/>
+            <a:ext cx="1188720" cy="466344"/>
           </a:xfrm>
           <a:prstGeom prst="rect">
             <a:avLst/>
@@ -4436,8 +4472,8 @@
         </p:nvCxnSpPr>
         <p:spPr>
           <a:xfrm>
-            <a:off x="5074920" y="338328"/>
-            <a:ext cx="0" cy="283464"/>
+            <a:off x="5468112" y="274320"/>
+            <a:ext cx="0" cy="411480"/>
           </a:xfrm>
           <a:prstGeom prst="bentConnector3">
             <a:avLst/>
@@ -4472,8 +4508,8 @@
         </p:nvSpPr>
         <p:spPr>
           <a:xfrm>
-            <a:off x="5285232" y="0"/>
-            <a:ext cx="8686800" cy="960120"/>
+            <a:off x="5687568" y="0"/>
+            <a:ext cx="8229600" cy="960120"/>
           </a:xfrm>
           <a:prstGeom prst="rect">
             <a:avLst/>
@@ -4517,8 +4553,8 @@
         </p:nvSpPr>
         <p:spPr>
           <a:xfrm>
-            <a:off x="14996159" y="0"/>
-            <a:ext cx="1645920" cy="960120"/>
+            <a:off x="14356080" y="0"/>
+            <a:ext cx="2103120" cy="960120"/>
           </a:xfrm>
           <a:prstGeom prst="rect">
             <a:avLst/>
@@ -4579,8 +4615,8 @@
         </p:blipFill>
         <p:spPr>
           <a:xfrm>
-            <a:off x="16916400" y="256032"/>
-            <a:ext cx="457200" cy="475488"/>
+            <a:off x="16751808" y="155448"/>
+            <a:ext cx="594360" cy="658368"/>
           </a:xfrm>
           <a:prstGeom prst="rect">
             <a:avLst/>
@@ -6328,10 +6364,10 @@
           <a:gradFill rotWithShape="1">
             <a:gsLst>
               <a:gs pos="0">
-                <a:srgbClr val="0F766E"/>
+                <a:srgbClr val="2E1065"/>
               </a:gs>
               <a:gs pos="100000">
-                <a:srgbClr val="13B5A6"/>
+                <a:srgbClr val="4C1D95"/>
               </a:gs>
             </a:gsLst>
             <a:lin scaled="0" ang="18600000"/>
@@ -6424,7 +6460,7 @@
           </a:prstGeom>
           <a:ln w="9525">
             <a:solidFill>
-              <a:srgbClr val="3FBFB0"/>
+              <a:srgbClr val="7E5BC2"/>
             </a:solidFill>
           </a:ln>
           <a:effectLst/>
@@ -6525,7 +6561,7 @@
             <a:r>
               <a:rPr sz="1300" b="0" i="0">
                 <a:solidFill>
-                  <a:srgbClr val="CCFBF1"/>
+                  <a:srgbClr val="D8C9F5"/>
                 </a:solidFill>
                 <a:latin typeface="Montserrat"/>
               </a:rPr>
@@ -6550,7 +6586,7 @@
           </a:prstGeom>
           <a:ln w="6350">
             <a:solidFill>
-              <a:srgbClr val="3FBFB0"/>
+              <a:srgbClr val="7E5BC2"/>
             </a:solidFill>
           </a:ln>
           <a:effectLst/>
@@ -6651,7 +6687,7 @@
             <a:r>
               <a:rPr sz="1300" b="0" i="0">
                 <a:solidFill>
-                  <a:srgbClr val="CCFBF1"/>
+                  <a:srgbClr val="D8C9F5"/>
                 </a:solidFill>
                 <a:latin typeface="Montserrat"/>
               </a:rPr>
@@ -6676,7 +6712,7 @@
           </a:prstGeom>
           <a:ln w="6350">
             <a:solidFill>
-              <a:srgbClr val="3FBFB0"/>
+              <a:srgbClr val="7E5BC2"/>
             </a:solidFill>
           </a:ln>
           <a:effectLst/>
@@ -6777,7 +6813,7 @@
             <a:r>
               <a:rPr sz="1300" b="0" i="0">
                 <a:solidFill>
-                  <a:srgbClr val="CCFBF1"/>
+                  <a:srgbClr val="D8C9F5"/>
                 </a:solidFill>
                 <a:latin typeface="Montserrat"/>
               </a:rPr>
@@ -7861,8 +7897,8 @@
         </p:blipFill>
         <p:spPr>
           <a:xfrm>
-            <a:off x="758952" y="292608"/>
-            <a:ext cx="2542032" cy="365760"/>
+            <a:off x="758952" y="256032"/>
+            <a:ext cx="2660904" cy="384048"/>
           </a:xfrm>
           <a:prstGeom prst="rect">
             <a:avLst/>
@@ -7877,8 +7913,8 @@
         </p:nvSpPr>
         <p:spPr>
           <a:xfrm>
-            <a:off x="3456432" y="0"/>
-            <a:ext cx="457200" cy="960120"/>
+            <a:off x="3474720" y="256032"/>
+            <a:ext cx="502920" cy="384048"/>
           </a:xfrm>
           <a:prstGeom prst="rect">
             <a:avLst/>
@@ -7903,7 +7939,7 @@
               </a:spcAft>
             </a:pPr>
             <a:r>
-              <a:rPr sz="1800" b="0" i="0">
+              <a:rPr sz="2000" b="0" i="0">
                 <a:solidFill>
                   <a:srgbClr val="6A707B"/>
                 </a:solidFill>
@@ -7930,8 +7966,8 @@
         </p:blipFill>
         <p:spPr>
           <a:xfrm>
-            <a:off x="3977639" y="338328"/>
-            <a:ext cx="749808" cy="292608"/>
+            <a:off x="4023360" y="256032"/>
+            <a:ext cx="1188720" cy="466344"/>
           </a:xfrm>
           <a:prstGeom prst="rect">
             <a:avLst/>
@@ -7946,8 +7982,8 @@
         </p:nvCxnSpPr>
         <p:spPr>
           <a:xfrm>
-            <a:off x="5074920" y="338328"/>
-            <a:ext cx="0" cy="283464"/>
+            <a:off x="5468112" y="274320"/>
+            <a:ext cx="0" cy="411480"/>
           </a:xfrm>
           <a:prstGeom prst="bentConnector3">
             <a:avLst/>
@@ -7982,8 +8018,8 @@
         </p:nvSpPr>
         <p:spPr>
           <a:xfrm>
-            <a:off x="5285232" y="0"/>
-            <a:ext cx="8686800" cy="960120"/>
+            <a:off x="5687568" y="0"/>
+            <a:ext cx="8229600" cy="960120"/>
           </a:xfrm>
           <a:prstGeom prst="rect">
             <a:avLst/>
@@ -8027,8 +8063,8 @@
         </p:nvSpPr>
         <p:spPr>
           <a:xfrm>
-            <a:off x="14996159" y="0"/>
-            <a:ext cx="1645920" cy="960120"/>
+            <a:off x="14356080" y="0"/>
+            <a:ext cx="2103120" cy="960120"/>
           </a:xfrm>
           <a:prstGeom prst="rect">
             <a:avLst/>
@@ -8089,8 +8125,8 @@
         </p:blipFill>
         <p:spPr>
           <a:xfrm>
-            <a:off x="16916400" y="256032"/>
-            <a:ext cx="457200" cy="475488"/>
+            <a:off x="16751808" y="155448"/>
+            <a:ext cx="594360" cy="658368"/>
           </a:xfrm>
           <a:prstGeom prst="rect">
             <a:avLst/>
@@ -8383,8 +8419,8 @@
         </p:nvSpPr>
         <p:spPr>
           <a:xfrm>
-            <a:off x="758952" y="3246120"/>
-            <a:ext cx="3154680" cy="5806440"/>
+            <a:off x="758952" y="3291840"/>
+            <a:ext cx="3154680" cy="4892040"/>
           </a:xfrm>
           <a:prstGeom prst="roundRect">
             <a:avLst>
@@ -8431,7 +8467,7 @@
         </p:nvSpPr>
         <p:spPr>
           <a:xfrm>
-            <a:off x="758952" y="3246120"/>
+            <a:off x="758952" y="3291840"/>
             <a:ext cx="3154680" cy="64008"/>
           </a:xfrm>
           <a:prstGeom prst="rect">
@@ -8475,12 +8511,12 @@
         </p:nvSpPr>
         <p:spPr>
           <a:xfrm>
-            <a:off x="978407" y="3538727"/>
-            <a:ext cx="603504" cy="603504"/>
+            <a:off x="1014983" y="3602736"/>
+            <a:ext cx="658368" cy="658368"/>
           </a:xfrm>
           <a:prstGeom prst="roundRect">
             <a:avLst>
-              <a:gd name="adj" fmla="val 18181"/>
+              <a:gd name="adj" fmla="val 19444"/>
             </a:avLst>
           </a:prstGeom>
           <a:solidFill>
@@ -8529,7 +8565,7 @@
         </p:blipFill>
         <p:spPr>
           <a:xfrm>
-            <a:off x="1097280" y="3657600"/>
+            <a:off x="1161287" y="3749039"/>
             <a:ext cx="365760" cy="365760"/>
           </a:xfrm>
           <a:prstGeom prst="rect">
@@ -8545,8 +8581,8 @@
         </p:nvSpPr>
         <p:spPr>
           <a:xfrm>
-            <a:off x="1691640" y="3557015"/>
-            <a:ext cx="2020824" cy="566928"/>
+            <a:off x="1837943" y="3602736"/>
+            <a:ext cx="1819656" cy="658368"/>
           </a:xfrm>
           <a:prstGeom prst="rect">
             <a:avLst/>
@@ -8590,8 +8626,8 @@
         </p:nvSpPr>
         <p:spPr>
           <a:xfrm>
-            <a:off x="978407" y="4297679"/>
-            <a:ext cx="2715768" cy="457200"/>
+            <a:off x="1014983" y="4480560"/>
+            <a:ext cx="2642616" cy="502920"/>
           </a:xfrm>
           <a:prstGeom prst="rect">
             <a:avLst/>
@@ -8616,13 +8652,13 @@
               </a:spcAft>
             </a:pPr>
             <a:r>
-              <a:rPr sz="2000" b="0" i="0">
+              <a:rPr sz="2500" b="0" i="0">
                 <a:solidFill>
                   <a:srgbClr val="1B1F26"/>
                 </a:solidFill>
                 <a:latin typeface="Montserrat Medium"/>
               </a:rPr>
-              <a:t>Intake Agent</a:t>
+              <a:t>Intake</a:t>
             </a:r>
           </a:p>
         </p:txBody>
@@ -8635,8 +8671,8 @@
         </p:nvSpPr>
         <p:spPr>
           <a:xfrm>
-            <a:off x="978407" y="4818888"/>
-            <a:ext cx="2715768" cy="1097280"/>
+            <a:off x="1014983" y="5120640"/>
+            <a:ext cx="2642616" cy="365760"/>
           </a:xfrm>
           <a:prstGeom prst="rect">
             <a:avLst/>
@@ -8651,63 +8687,73 @@
           <a:p>
             <a:pPr algn="l">
               <a:lnSpc>
-                <a:spcPct val="120000"/>
-              </a:lnSpc>
-              <a:spcBef>
-                <a:spcPts val="0"/>
-              </a:spcBef>
-              <a:spcAft>
-                <a:spcPts val="0"/>
-              </a:spcAft>
-            </a:pPr>
-            <a:r>
-              <a:rPr sz="1300" b="0" i="0">
-                <a:solidFill>
-                  <a:srgbClr val="6A707B"/>
-                </a:solidFill>
-                <a:latin typeface="Montserrat"/>
-              </a:rPr>
-              <a:t>Auto-ingests requests, cleans maverick descriptions, classifies &amp; enriches spend.</a:t>
-            </a:r>
-          </a:p>
-        </p:txBody>
-      </p:sp>
-      <p:cxnSp>
-        <p:nvCxnSpPr>
-          <p:cNvPr id="25" name="Connector 24"/>
-          <p:cNvCxnSpPr/>
-          <p:nvPr/>
-        </p:nvCxnSpPr>
-        <p:spPr>
-          <a:xfrm>
-            <a:off x="978407" y="6035040"/>
-            <a:ext cx="2715769" cy="0"/>
-          </a:xfrm>
-          <a:prstGeom prst="bentConnector3">
-            <a:avLst/>
-          </a:prstGeom>
-          <a:ln w="9525">
-            <a:solidFill>
-              <a:srgbClr val="E2E4EA"/>
-            </a:solidFill>
+                <a:spcPct val="100000"/>
+              </a:lnSpc>
+              <a:spcBef>
+                <a:spcPts val="0"/>
+              </a:spcBef>
+              <a:spcAft>
+                <a:spcPts val="0"/>
+              </a:spcAft>
+            </a:pPr>
+            <a:r>
+              <a:rPr sz="1400" b="0" i="0">
+                <a:solidFill>
+                  <a:srgbClr val="7C3AED"/>
+                </a:solidFill>
+                <a:latin typeface="Montserrat Medium"/>
+              </a:rPr>
+              <a:t>Intake &amp; Enrichment</a:t>
+            </a:r>
+          </a:p>
+        </p:txBody>
+      </p:sp>
+      <p:sp>
+        <p:nvSpPr>
+          <p:cNvPr id="25" name="Rounded Rectangle 24"/>
+          <p:cNvSpPr/>
+          <p:nvPr/>
+        </p:nvSpPr>
+        <p:spPr>
+          <a:xfrm>
+            <a:off x="1014983" y="5687568"/>
+            <a:ext cx="2642616" cy="438912"/>
+          </a:xfrm>
+          <a:prstGeom prst="roundRect">
+            <a:avLst>
+              <a:gd name="adj" fmla="val 50000"/>
+            </a:avLst>
+          </a:prstGeom>
+          <a:solidFill>
+            <a:srgbClr val="F1EAFC"/>
+          </a:solidFill>
+          <a:ln>
+            <a:noFill/>
           </a:ln>
           <a:effectLst/>
         </p:spPr>
         <p:style>
-          <a:lnRef idx="2">
+          <a:lnRef idx="1">
             <a:schemeClr val="accent1"/>
           </a:lnRef>
-          <a:fillRef idx="0">
+          <a:fillRef idx="3">
             <a:schemeClr val="accent1"/>
           </a:fillRef>
-          <a:effectRef idx="1">
+          <a:effectRef idx="2">
             <a:schemeClr val="accent1"/>
           </a:effectRef>
           <a:fontRef idx="minor">
-            <a:schemeClr val="tx1"/>
+            <a:schemeClr val="lt1"/>
           </a:fontRef>
         </p:style>
-      </p:cxnSp>
+        <p:txBody>
+          <a:bodyPr rtlCol="0" anchor="ctr"/>
+          <a:lstStyle/>
+          <a:p>
+            <a:pPr algn="ctr"/>
+          </a:p>
+        </p:txBody>
+      </p:sp>
       <p:sp>
         <p:nvSpPr>
           <p:cNvPr id="26" name="TextBox 25"/>
@@ -8716,21 +8762,21 @@
         </p:nvSpPr>
         <p:spPr>
           <a:xfrm>
-            <a:off x="978407" y="6190488"/>
-            <a:ext cx="2715768" cy="182880"/>
-          </a:xfrm>
-          <a:prstGeom prst="rect">
-            <a:avLst/>
-          </a:prstGeom>
-          <a:noFill/>
-        </p:spPr>
-        <p:txBody>
-          <a:bodyPr wrap="square" lIns="0" rIns="0" tIns="0" bIns="0" anchor="t">
-            <a:noAutofit/>
-          </a:bodyPr>
-          <a:lstStyle/>
-          <a:p>
-            <a:pPr algn="l">
+            <a:off x="1014983" y="5687568"/>
+            <a:ext cx="2642616" cy="438912"/>
+          </a:xfrm>
+          <a:prstGeom prst="rect">
+            <a:avLst/>
+          </a:prstGeom>
+          <a:noFill/>
+        </p:spPr>
+        <p:txBody>
+          <a:bodyPr wrap="square" lIns="0" rIns="0" tIns="0" bIns="0" anchor="ctr">
+            <a:noAutofit/>
+          </a:bodyPr>
+          <a:lstStyle/>
+          <a:p>
+            <a:pPr algn="ctr">
               <a:lnSpc>
                 <a:spcPct val="100000"/>
               </a:lnSpc>
@@ -8742,59 +8788,60 @@
               </a:spcAft>
             </a:pPr>
             <a:r>
-              <a:rPr sz="950" b="1" i="0" spc="60">
-                <a:solidFill>
-                  <a:srgbClr val="6A707B"/>
-                </a:solidFill>
-                <a:latin typeface="Consolas"/>
-              </a:rPr>
-              <a:t>↓ AERCHAIN CAPABILITY</a:t>
-            </a:r>
-          </a:p>
-        </p:txBody>
-      </p:sp>
-      <p:sp>
-        <p:nvSpPr>
-          <p:cNvPr id="27" name="TextBox 26"/>
-          <p:cNvSpPr txBox="1"/>
-          <p:nvPr/>
-        </p:nvSpPr>
-        <p:spPr>
-          <a:xfrm>
-            <a:off x="978407" y="6446520"/>
-            <a:ext cx="2715768" cy="548640"/>
-          </a:xfrm>
-          <a:prstGeom prst="rect">
-            <a:avLst/>
-          </a:prstGeom>
-          <a:noFill/>
-        </p:spPr>
-        <p:txBody>
-          <a:bodyPr wrap="square" lIns="0" rIns="0" tIns="0" bIns="0" anchor="t">
-            <a:noAutofit/>
-          </a:bodyPr>
-          <a:lstStyle/>
-          <a:p>
-            <a:pPr algn="l">
-              <a:lnSpc>
-                <a:spcPct val="105000"/>
-              </a:lnSpc>
-              <a:spcBef>
-                <a:spcPts val="0"/>
-              </a:spcBef>
-              <a:spcAft>
-                <a:spcPts val="0"/>
-              </a:spcAft>
-            </a:pPr>
-            <a:r>
-              <a:rPr sz="1500" b="0" i="0">
-                <a:solidFill>
-                  <a:srgbClr val="7C3AED"/>
-                </a:solidFill>
-                <a:latin typeface="Montserrat Medium"/>
-              </a:rPr>
-              <a:t>Intake &amp; Enrichment</a:t>
-            </a:r>
+              <a:rPr sz="1350" b="0" i="0">
+                <a:solidFill>
+                  <a:srgbClr val="6D28D9"/>
+                </a:solidFill>
+                <a:latin typeface="Montserrat SemiBold"/>
+              </a:rPr>
+              <a:t>Auto-ingest PRs</a:t>
+            </a:r>
+          </a:p>
+        </p:txBody>
+      </p:sp>
+      <p:sp>
+        <p:nvSpPr>
+          <p:cNvPr id="27" name="Rounded Rectangle 26"/>
+          <p:cNvSpPr/>
+          <p:nvPr/>
+        </p:nvSpPr>
+        <p:spPr>
+          <a:xfrm>
+            <a:off x="1014983" y="6236208"/>
+            <a:ext cx="2642616" cy="438912"/>
+          </a:xfrm>
+          <a:prstGeom prst="roundRect">
+            <a:avLst>
+              <a:gd name="adj" fmla="val 50000"/>
+            </a:avLst>
+          </a:prstGeom>
+          <a:solidFill>
+            <a:srgbClr val="F1EAFC"/>
+          </a:solidFill>
+          <a:ln>
+            <a:noFill/>
+          </a:ln>
+          <a:effectLst/>
+        </p:spPr>
+        <p:style>
+          <a:lnRef idx="1">
+            <a:schemeClr val="accent1"/>
+          </a:lnRef>
+          <a:fillRef idx="3">
+            <a:schemeClr val="accent1"/>
+          </a:fillRef>
+          <a:effectRef idx="2">
+            <a:schemeClr val="accent1"/>
+          </a:effectRef>
+          <a:fontRef idx="minor">
+            <a:schemeClr val="lt1"/>
+          </a:fontRef>
+        </p:style>
+        <p:txBody>
+          <a:bodyPr rtlCol="0" anchor="ctr"/>
+          <a:lstStyle/>
+          <a:p>
+            <a:pPr algn="ctr"/>
           </a:p>
         </p:txBody>
       </p:sp>
@@ -8806,39 +8853,39 @@
         </p:nvSpPr>
         <p:spPr>
           <a:xfrm>
-            <a:off x="978407" y="7104888"/>
-            <a:ext cx="2715768" cy="1371600"/>
-          </a:xfrm>
-          <a:prstGeom prst="rect">
-            <a:avLst/>
-          </a:prstGeom>
-          <a:noFill/>
-        </p:spPr>
-        <p:txBody>
-          <a:bodyPr wrap="square" lIns="0" rIns="0" tIns="0" bIns="0" anchor="t">
-            <a:noAutofit/>
-          </a:bodyPr>
-          <a:lstStyle/>
-          <a:p>
-            <a:pPr algn="l">
-              <a:lnSpc>
-                <a:spcPct val="122000"/>
-              </a:lnSpc>
-              <a:spcBef>
-                <a:spcPts val="0"/>
-              </a:spcBef>
-              <a:spcAft>
-                <a:spcPts val="0"/>
-              </a:spcAft>
-            </a:pPr>
-            <a:r>
-              <a:rPr sz="1200" b="0" i="0">
-                <a:solidFill>
-                  <a:srgbClr val="484E59"/>
-                </a:solidFill>
-                <a:latin typeface="Montserrat"/>
-              </a:rPr>
-              <a:t>Parallel sub-agents auto-tag GL, cost centre and taxonomy, and raise clarifying questions before the cycle starts.</a:t>
+            <a:off x="1014983" y="6236208"/>
+            <a:ext cx="2642616" cy="438912"/>
+          </a:xfrm>
+          <a:prstGeom prst="rect">
+            <a:avLst/>
+          </a:prstGeom>
+          <a:noFill/>
+        </p:spPr>
+        <p:txBody>
+          <a:bodyPr wrap="square" lIns="0" rIns="0" tIns="0" bIns="0" anchor="ctr">
+            <a:noAutofit/>
+          </a:bodyPr>
+          <a:lstStyle/>
+          <a:p>
+            <a:pPr algn="ctr">
+              <a:lnSpc>
+                <a:spcPct val="100000"/>
+              </a:lnSpc>
+              <a:spcBef>
+                <a:spcPts val="0"/>
+              </a:spcBef>
+              <a:spcAft>
+                <a:spcPts val="0"/>
+              </a:spcAft>
+            </a:pPr>
+            <a:r>
+              <a:rPr sz="1350" b="0" i="0">
+                <a:solidFill>
+                  <a:srgbClr val="6D28D9"/>
+                </a:solidFill>
+                <a:latin typeface="Montserrat SemiBold"/>
+              </a:rPr>
+              <a:t>Clean &amp; classify</a:t>
             </a:r>
           </a:p>
         </p:txBody>
@@ -8851,12 +8898,103 @@
         </p:nvSpPr>
         <p:spPr>
           <a:xfrm>
-            <a:off x="978407" y="8531352"/>
-            <a:ext cx="2715768" cy="329184"/>
+            <a:off x="1014983" y="6784848"/>
+            <a:ext cx="2642616" cy="438912"/>
           </a:xfrm>
           <a:prstGeom prst="roundRect">
             <a:avLst>
-              <a:gd name="adj" fmla="val 13888"/>
+              <a:gd name="adj" fmla="val 50000"/>
+            </a:avLst>
+          </a:prstGeom>
+          <a:solidFill>
+            <a:srgbClr val="F1EAFC"/>
+          </a:solidFill>
+          <a:ln>
+            <a:noFill/>
+          </a:ln>
+          <a:effectLst/>
+        </p:spPr>
+        <p:style>
+          <a:lnRef idx="1">
+            <a:schemeClr val="accent1"/>
+          </a:lnRef>
+          <a:fillRef idx="3">
+            <a:schemeClr val="accent1"/>
+          </a:fillRef>
+          <a:effectRef idx="2">
+            <a:schemeClr val="accent1"/>
+          </a:effectRef>
+          <a:fontRef idx="minor">
+            <a:schemeClr val="lt1"/>
+          </a:fontRef>
+        </p:style>
+        <p:txBody>
+          <a:bodyPr rtlCol="0" anchor="ctr"/>
+          <a:lstStyle/>
+          <a:p>
+            <a:pPr algn="ctr"/>
+          </a:p>
+        </p:txBody>
+      </p:sp>
+      <p:sp>
+        <p:nvSpPr>
+          <p:cNvPr id="30" name="TextBox 29"/>
+          <p:cNvSpPr txBox="1"/>
+          <p:nvPr/>
+        </p:nvSpPr>
+        <p:spPr>
+          <a:xfrm>
+            <a:off x="1014983" y="6784848"/>
+            <a:ext cx="2642616" cy="438912"/>
+          </a:xfrm>
+          <a:prstGeom prst="rect">
+            <a:avLst/>
+          </a:prstGeom>
+          <a:noFill/>
+        </p:spPr>
+        <p:txBody>
+          <a:bodyPr wrap="square" lIns="0" rIns="0" tIns="0" bIns="0" anchor="ctr">
+            <a:noAutofit/>
+          </a:bodyPr>
+          <a:lstStyle/>
+          <a:p>
+            <a:pPr algn="ctr">
+              <a:lnSpc>
+                <a:spcPct val="100000"/>
+              </a:lnSpc>
+              <a:spcBef>
+                <a:spcPts val="0"/>
+              </a:spcBef>
+              <a:spcAft>
+                <a:spcPts val="0"/>
+              </a:spcAft>
+            </a:pPr>
+            <a:r>
+              <a:rPr sz="1350" b="0" i="0">
+                <a:solidFill>
+                  <a:srgbClr val="6D28D9"/>
+                </a:solidFill>
+                <a:latin typeface="Montserrat SemiBold"/>
+              </a:rPr>
+              <a:t>Enrich &amp; tag spend</a:t>
+            </a:r>
+          </a:p>
+        </p:txBody>
+      </p:sp>
+      <p:sp>
+        <p:nvSpPr>
+          <p:cNvPr id="31" name="Rounded Rectangle 30"/>
+          <p:cNvSpPr/>
+          <p:nvPr/>
+        </p:nvSpPr>
+        <p:spPr>
+          <a:xfrm>
+            <a:off x="1014983" y="7516368"/>
+            <a:ext cx="2642616" cy="420624"/>
+          </a:xfrm>
+          <a:prstGeom prst="roundRect">
+            <a:avLst>
+              <a:gd name="adj" fmla="val 50000"/>
             </a:avLst>
           </a:prstGeom>
           <a:solidFill>
@@ -8893,14 +9031,14 @@
       </p:sp>
       <p:sp>
         <p:nvSpPr>
-          <p:cNvPr id="30" name="TextBox 29"/>
-          <p:cNvSpPr txBox="1"/>
-          <p:nvPr/>
-        </p:nvSpPr>
-        <p:spPr>
-          <a:xfrm>
-            <a:off x="978407" y="8531352"/>
-            <a:ext cx="2715768" cy="329184"/>
+          <p:cNvPr id="32" name="TextBox 31"/>
+          <p:cNvSpPr txBox="1"/>
+          <p:nvPr/>
+        </p:nvSpPr>
+        <p:spPr>
+          <a:xfrm>
+            <a:off x="1014983" y="7516368"/>
+            <a:ext cx="2642616" cy="420624"/>
           </a:xfrm>
           <a:prstGeom prst="rect">
             <a:avLst/>
@@ -8925,7 +9063,7 @@
               </a:spcAft>
             </a:pPr>
             <a:r>
-              <a:rPr sz="1100" b="1" i="0" spc="80">
+              <a:rPr sz="1100" b="0" i="0" spc="80">
                 <a:solidFill>
                   <a:srgbClr val="146B3F"/>
                 </a:solidFill>
@@ -8938,14 +9076,14 @@
       </p:sp>
       <p:sp>
         <p:nvSpPr>
-          <p:cNvPr id="31" name="Rounded Rectangle 30"/>
+          <p:cNvPr id="33" name="Rounded Rectangle 32"/>
           <p:cNvSpPr/>
           <p:nvPr/>
         </p:nvSpPr>
         <p:spPr>
           <a:xfrm>
-            <a:off x="4069080" y="3246120"/>
-            <a:ext cx="3154680" cy="5806440"/>
+            <a:off x="4069080" y="3291840"/>
+            <a:ext cx="3154680" cy="4892040"/>
           </a:xfrm>
           <a:prstGeom prst="roundRect">
             <a:avLst>
@@ -8986,13 +9124,13 @@
       </p:sp>
       <p:sp>
         <p:nvSpPr>
-          <p:cNvPr id="32" name="Rectangle 31"/>
+          <p:cNvPr id="34" name="Rectangle 33"/>
           <p:cNvSpPr/>
           <p:nvPr/>
         </p:nvSpPr>
         <p:spPr>
           <a:xfrm>
-            <a:off x="4069080" y="3246120"/>
+            <a:off x="4069080" y="3291840"/>
             <a:ext cx="3154680" cy="64008"/>
           </a:xfrm>
           <a:prstGeom prst="rect">
@@ -9030,18 +9168,18 @@
       </p:sp>
       <p:sp>
         <p:nvSpPr>
-          <p:cNvPr id="33" name="Rounded Rectangle 32"/>
+          <p:cNvPr id="35" name="Rounded Rectangle 34"/>
           <p:cNvSpPr/>
           <p:nvPr/>
         </p:nvSpPr>
         <p:spPr>
           <a:xfrm>
-            <a:off x="4288536" y="3538727"/>
-            <a:ext cx="603504" cy="603504"/>
+            <a:off x="4325112" y="3602736"/>
+            <a:ext cx="658368" cy="658368"/>
           </a:xfrm>
           <a:prstGeom prst="roundRect">
             <a:avLst>
-              <a:gd name="adj" fmla="val 18181"/>
+              <a:gd name="adj" fmla="val 19444"/>
             </a:avLst>
           </a:prstGeom>
           <a:solidFill>
@@ -9076,7 +9214,7 @@
       </p:sp>
       <p:pic>
         <p:nvPicPr>
-          <p:cNvPr id="34" name="Picture 33" descr="icon_sourcing_purple.png"/>
+          <p:cNvPr id="36" name="Picture 35" descr="icon_sourcing_purple.png"/>
           <p:cNvPicPr>
             <a:picLocks noChangeAspect="1"/>
           </p:cNvPicPr>
@@ -9090,7 +9228,7 @@
         </p:blipFill>
         <p:spPr>
           <a:xfrm>
-            <a:off x="4407408" y="3657600"/>
+            <a:off x="4471416" y="3749039"/>
             <a:ext cx="365760" cy="365760"/>
           </a:xfrm>
           <a:prstGeom prst="rect">
@@ -9100,14 +9238,14 @@
       </p:pic>
       <p:sp>
         <p:nvSpPr>
-          <p:cNvPr id="35" name="TextBox 34"/>
-          <p:cNvSpPr txBox="1"/>
-          <p:nvPr/>
-        </p:nvSpPr>
-        <p:spPr>
-          <a:xfrm>
-            <a:off x="5001768" y="3557015"/>
-            <a:ext cx="2020824" cy="566928"/>
+          <p:cNvPr id="37" name="TextBox 36"/>
+          <p:cNvSpPr txBox="1"/>
+          <p:nvPr/>
+        </p:nvSpPr>
+        <p:spPr>
+          <a:xfrm>
+            <a:off x="5148072" y="3602736"/>
+            <a:ext cx="1819656" cy="658368"/>
           </a:xfrm>
           <a:prstGeom prst="rect">
             <a:avLst/>
@@ -9145,14 +9283,14 @@
       </p:sp>
       <p:sp>
         <p:nvSpPr>
-          <p:cNvPr id="36" name="TextBox 35"/>
-          <p:cNvSpPr txBox="1"/>
-          <p:nvPr/>
-        </p:nvSpPr>
-        <p:spPr>
-          <a:xfrm>
-            <a:off x="4288536" y="4297679"/>
-            <a:ext cx="2715768" cy="457200"/>
+          <p:cNvPr id="38" name="TextBox 37"/>
+          <p:cNvSpPr txBox="1"/>
+          <p:nvPr/>
+        </p:nvSpPr>
+        <p:spPr>
+          <a:xfrm>
+            <a:off x="4325112" y="4480560"/>
+            <a:ext cx="2642616" cy="502920"/>
           </a:xfrm>
           <a:prstGeom prst="rect">
             <a:avLst/>
@@ -9177,27 +9315,27 @@
               </a:spcAft>
             </a:pPr>
             <a:r>
-              <a:rPr sz="2000" b="0" i="0">
+              <a:rPr sz="2500" b="0" i="0">
                 <a:solidFill>
                   <a:srgbClr val="1B1F26"/>
                 </a:solidFill>
                 <a:latin typeface="Montserrat Medium"/>
               </a:rPr>
-              <a:t>Sourcing Agent</a:t>
-            </a:r>
-          </a:p>
-        </p:txBody>
-      </p:sp>
-      <p:sp>
-        <p:nvSpPr>
-          <p:cNvPr id="37" name="TextBox 36"/>
-          <p:cNvSpPr txBox="1"/>
-          <p:nvPr/>
-        </p:nvSpPr>
-        <p:spPr>
-          <a:xfrm>
-            <a:off x="4288536" y="4818888"/>
-            <a:ext cx="2715768" cy="1097280"/>
+              <a:t>Sourcing</a:t>
+            </a:r>
+          </a:p>
+        </p:txBody>
+      </p:sp>
+      <p:sp>
+        <p:nvSpPr>
+          <p:cNvPr id="39" name="TextBox 38"/>
+          <p:cNvSpPr txBox="1"/>
+          <p:nvPr/>
+        </p:nvSpPr>
+        <p:spPr>
+          <a:xfrm>
+            <a:off x="4325112" y="5120640"/>
+            <a:ext cx="2642616" cy="365760"/>
           </a:xfrm>
           <a:prstGeom prst="rect">
             <a:avLst/>
@@ -9212,86 +9350,96 @@
           <a:p>
             <a:pPr algn="l">
               <a:lnSpc>
-                <a:spcPct val="120000"/>
-              </a:lnSpc>
-              <a:spcBef>
-                <a:spcPts val="0"/>
-              </a:spcBef>
-              <a:spcAft>
-                <a:spcPts val="0"/>
-              </a:spcAft>
-            </a:pPr>
-            <a:r>
-              <a:rPr sz="1300" b="0" i="0">
-                <a:solidFill>
-                  <a:srgbClr val="6A707B"/>
-                </a:solidFill>
-                <a:latin typeface="Montserrat"/>
-              </a:rPr>
-              <a:t>Scouts the market and runs outreach across the existing supplier base.</a:t>
-            </a:r>
-          </a:p>
-        </p:txBody>
-      </p:sp>
-      <p:cxnSp>
-        <p:nvCxnSpPr>
-          <p:cNvPr id="38" name="Connector 37"/>
-          <p:cNvCxnSpPr/>
-          <p:nvPr/>
-        </p:nvCxnSpPr>
-        <p:spPr>
-          <a:xfrm>
-            <a:off x="4288536" y="6035040"/>
-            <a:ext cx="2715768" cy="0"/>
-          </a:xfrm>
-          <a:prstGeom prst="bentConnector3">
-            <a:avLst/>
-          </a:prstGeom>
-          <a:ln w="9525">
-            <a:solidFill>
-              <a:srgbClr val="E2E4EA"/>
-            </a:solidFill>
+                <a:spcPct val="100000"/>
+              </a:lnSpc>
+              <a:spcBef>
+                <a:spcPts val="0"/>
+              </a:spcBef>
+              <a:spcAft>
+                <a:spcPts val="0"/>
+              </a:spcAft>
+            </a:pPr>
+            <a:r>
+              <a:rPr sz="1400" b="0" i="0">
+                <a:solidFill>
+                  <a:srgbClr val="7C3AED"/>
+                </a:solidFill>
+                <a:latin typeface="Montserrat Medium"/>
+              </a:rPr>
+              <a:t>Multi-Agent RFQ</a:t>
+            </a:r>
+          </a:p>
+        </p:txBody>
+      </p:sp>
+      <p:sp>
+        <p:nvSpPr>
+          <p:cNvPr id="40" name="Rounded Rectangle 39"/>
+          <p:cNvSpPr/>
+          <p:nvPr/>
+        </p:nvSpPr>
+        <p:spPr>
+          <a:xfrm>
+            <a:off x="4325112" y="5687568"/>
+            <a:ext cx="2642616" cy="438912"/>
+          </a:xfrm>
+          <a:prstGeom prst="roundRect">
+            <a:avLst>
+              <a:gd name="adj" fmla="val 50000"/>
+            </a:avLst>
+          </a:prstGeom>
+          <a:solidFill>
+            <a:srgbClr val="F1EAFC"/>
+          </a:solidFill>
+          <a:ln>
+            <a:noFill/>
           </a:ln>
           <a:effectLst/>
         </p:spPr>
         <p:style>
-          <a:lnRef idx="2">
+          <a:lnRef idx="1">
             <a:schemeClr val="accent1"/>
           </a:lnRef>
-          <a:fillRef idx="0">
+          <a:fillRef idx="3">
             <a:schemeClr val="accent1"/>
           </a:fillRef>
-          <a:effectRef idx="1">
+          <a:effectRef idx="2">
             <a:schemeClr val="accent1"/>
           </a:effectRef>
           <a:fontRef idx="minor">
-            <a:schemeClr val="tx1"/>
+            <a:schemeClr val="lt1"/>
           </a:fontRef>
         </p:style>
-      </p:cxnSp>
-      <p:sp>
-        <p:nvSpPr>
-          <p:cNvPr id="39" name="TextBox 38"/>
-          <p:cNvSpPr txBox="1"/>
-          <p:nvPr/>
-        </p:nvSpPr>
-        <p:spPr>
-          <a:xfrm>
-            <a:off x="4288536" y="6190488"/>
-            <a:ext cx="2715768" cy="182880"/>
-          </a:xfrm>
-          <a:prstGeom prst="rect">
-            <a:avLst/>
-          </a:prstGeom>
-          <a:noFill/>
-        </p:spPr>
-        <p:txBody>
-          <a:bodyPr wrap="square" lIns="0" rIns="0" tIns="0" bIns="0" anchor="t">
-            <a:noAutofit/>
-          </a:bodyPr>
-          <a:lstStyle/>
-          <a:p>
-            <a:pPr algn="l">
+        <p:txBody>
+          <a:bodyPr rtlCol="0" anchor="ctr"/>
+          <a:lstStyle/>
+          <a:p>
+            <a:pPr algn="ctr"/>
+          </a:p>
+        </p:txBody>
+      </p:sp>
+      <p:sp>
+        <p:nvSpPr>
+          <p:cNvPr id="41" name="TextBox 40"/>
+          <p:cNvSpPr txBox="1"/>
+          <p:nvPr/>
+        </p:nvSpPr>
+        <p:spPr>
+          <a:xfrm>
+            <a:off x="4325112" y="5687568"/>
+            <a:ext cx="2642616" cy="438912"/>
+          </a:xfrm>
+          <a:prstGeom prst="rect">
+            <a:avLst/>
+          </a:prstGeom>
+          <a:noFill/>
+        </p:spPr>
+        <p:txBody>
+          <a:bodyPr wrap="square" lIns="0" rIns="0" tIns="0" bIns="0" anchor="ctr">
+            <a:noAutofit/>
+          </a:bodyPr>
+          <a:lstStyle/>
+          <a:p>
+            <a:pPr algn="ctr">
               <a:lnSpc>
                 <a:spcPct val="100000"/>
               </a:lnSpc>
@@ -9303,103 +9451,13 @@
               </a:spcAft>
             </a:pPr>
             <a:r>
-              <a:rPr sz="950" b="1" i="0" spc="60">
-                <a:solidFill>
-                  <a:srgbClr val="6A707B"/>
-                </a:solidFill>
-                <a:latin typeface="Consolas"/>
-              </a:rPr>
-              <a:t>↓ AERCHAIN CAPABILITY</a:t>
-            </a:r>
-          </a:p>
-        </p:txBody>
-      </p:sp>
-      <p:sp>
-        <p:nvSpPr>
-          <p:cNvPr id="40" name="TextBox 39"/>
-          <p:cNvSpPr txBox="1"/>
-          <p:nvPr/>
-        </p:nvSpPr>
-        <p:spPr>
-          <a:xfrm>
-            <a:off x="4288536" y="6446520"/>
-            <a:ext cx="2715768" cy="548640"/>
-          </a:xfrm>
-          <a:prstGeom prst="rect">
-            <a:avLst/>
-          </a:prstGeom>
-          <a:noFill/>
-        </p:spPr>
-        <p:txBody>
-          <a:bodyPr wrap="square" lIns="0" rIns="0" tIns="0" bIns="0" anchor="t">
-            <a:noAutofit/>
-          </a:bodyPr>
-          <a:lstStyle/>
-          <a:p>
-            <a:pPr algn="l">
-              <a:lnSpc>
-                <a:spcPct val="105000"/>
-              </a:lnSpc>
-              <a:spcBef>
-                <a:spcPts val="0"/>
-              </a:spcBef>
-              <a:spcAft>
-                <a:spcPts val="0"/>
-              </a:spcAft>
-            </a:pPr>
-            <a:r>
-              <a:rPr sz="1500" b="0" i="0">
-                <a:solidFill>
-                  <a:srgbClr val="7C3AED"/>
-                </a:solidFill>
-                <a:latin typeface="Montserrat Medium"/>
-              </a:rPr>
-              <a:t>Multi-Agent RFQ</a:t>
-            </a:r>
-          </a:p>
-        </p:txBody>
-      </p:sp>
-      <p:sp>
-        <p:nvSpPr>
-          <p:cNvPr id="41" name="TextBox 40"/>
-          <p:cNvSpPr txBox="1"/>
-          <p:nvPr/>
-        </p:nvSpPr>
-        <p:spPr>
-          <a:xfrm>
-            <a:off x="4288536" y="7104888"/>
-            <a:ext cx="2715768" cy="1371600"/>
-          </a:xfrm>
-          <a:prstGeom prst="rect">
-            <a:avLst/>
-          </a:prstGeom>
-          <a:noFill/>
-        </p:spPr>
-        <p:txBody>
-          <a:bodyPr wrap="square" lIns="0" rIns="0" tIns="0" bIns="0" anchor="t">
-            <a:noAutofit/>
-          </a:bodyPr>
-          <a:lstStyle/>
-          <a:p>
-            <a:pPr algn="l">
-              <a:lnSpc>
-                <a:spcPct val="122000"/>
-              </a:lnSpc>
-              <a:spcBef>
-                <a:spcPts val="0"/>
-              </a:spcBef>
-              <a:spcAft>
-                <a:spcPts val="0"/>
-              </a:spcAft>
-            </a:pPr>
-            <a:r>
-              <a:rPr sz="1200" b="0" i="0">
-                <a:solidFill>
-                  <a:srgbClr val="484E59"/>
-                </a:solidFill>
-                <a:latin typeface="Montserrat"/>
-              </a:rPr>
-              <a:t>Auto-builds SOW, scope and T&amp;Cs, then runs outreach, follow-up, query clarification and bid extraction autonomously.</a:t>
+              <a:rPr sz="1350" b="0" i="0">
+                <a:solidFill>
+                  <a:srgbClr val="6D28D9"/>
+                </a:solidFill>
+                <a:latin typeface="Montserrat SemiBold"/>
+              </a:rPr>
+              <a:t>Build RFQ pack</a:t>
             </a:r>
           </a:p>
         </p:txBody>
@@ -9412,12 +9470,194 @@
         </p:nvSpPr>
         <p:spPr>
           <a:xfrm>
-            <a:off x="4288536" y="8531352"/>
-            <a:ext cx="2715768" cy="329184"/>
+            <a:off x="4325112" y="6236208"/>
+            <a:ext cx="2642616" cy="438912"/>
           </a:xfrm>
           <a:prstGeom prst="roundRect">
             <a:avLst>
-              <a:gd name="adj" fmla="val 13888"/>
+              <a:gd name="adj" fmla="val 50000"/>
+            </a:avLst>
+          </a:prstGeom>
+          <a:solidFill>
+            <a:srgbClr val="F1EAFC"/>
+          </a:solidFill>
+          <a:ln>
+            <a:noFill/>
+          </a:ln>
+          <a:effectLst/>
+        </p:spPr>
+        <p:style>
+          <a:lnRef idx="1">
+            <a:schemeClr val="accent1"/>
+          </a:lnRef>
+          <a:fillRef idx="3">
+            <a:schemeClr val="accent1"/>
+          </a:fillRef>
+          <a:effectRef idx="2">
+            <a:schemeClr val="accent1"/>
+          </a:effectRef>
+          <a:fontRef idx="minor">
+            <a:schemeClr val="lt1"/>
+          </a:fontRef>
+        </p:style>
+        <p:txBody>
+          <a:bodyPr rtlCol="0" anchor="ctr"/>
+          <a:lstStyle/>
+          <a:p>
+            <a:pPr algn="ctr"/>
+          </a:p>
+        </p:txBody>
+      </p:sp>
+      <p:sp>
+        <p:nvSpPr>
+          <p:cNvPr id="43" name="TextBox 42"/>
+          <p:cNvSpPr txBox="1"/>
+          <p:nvPr/>
+        </p:nvSpPr>
+        <p:spPr>
+          <a:xfrm>
+            <a:off x="4325112" y="6236208"/>
+            <a:ext cx="2642616" cy="438912"/>
+          </a:xfrm>
+          <a:prstGeom prst="rect">
+            <a:avLst/>
+          </a:prstGeom>
+          <a:noFill/>
+        </p:spPr>
+        <p:txBody>
+          <a:bodyPr wrap="square" lIns="0" rIns="0" tIns="0" bIns="0" anchor="ctr">
+            <a:noAutofit/>
+          </a:bodyPr>
+          <a:lstStyle/>
+          <a:p>
+            <a:pPr algn="ctr">
+              <a:lnSpc>
+                <a:spcPct val="100000"/>
+              </a:lnSpc>
+              <a:spcBef>
+                <a:spcPts val="0"/>
+              </a:spcBef>
+              <a:spcAft>
+                <a:spcPts val="0"/>
+              </a:spcAft>
+            </a:pPr>
+            <a:r>
+              <a:rPr sz="1350" b="0" i="0">
+                <a:solidFill>
+                  <a:srgbClr val="6D28D9"/>
+                </a:solidFill>
+                <a:latin typeface="Montserrat SemiBold"/>
+              </a:rPr>
+              <a:t>Run outreach</a:t>
+            </a:r>
+          </a:p>
+        </p:txBody>
+      </p:sp>
+      <p:sp>
+        <p:nvSpPr>
+          <p:cNvPr id="44" name="Rounded Rectangle 43"/>
+          <p:cNvSpPr/>
+          <p:nvPr/>
+        </p:nvSpPr>
+        <p:spPr>
+          <a:xfrm>
+            <a:off x="4325112" y="6784848"/>
+            <a:ext cx="2642616" cy="438912"/>
+          </a:xfrm>
+          <a:prstGeom prst="roundRect">
+            <a:avLst>
+              <a:gd name="adj" fmla="val 50000"/>
+            </a:avLst>
+          </a:prstGeom>
+          <a:solidFill>
+            <a:srgbClr val="F1EAFC"/>
+          </a:solidFill>
+          <a:ln>
+            <a:noFill/>
+          </a:ln>
+          <a:effectLst/>
+        </p:spPr>
+        <p:style>
+          <a:lnRef idx="1">
+            <a:schemeClr val="accent1"/>
+          </a:lnRef>
+          <a:fillRef idx="3">
+            <a:schemeClr val="accent1"/>
+          </a:fillRef>
+          <a:effectRef idx="2">
+            <a:schemeClr val="accent1"/>
+          </a:effectRef>
+          <a:fontRef idx="minor">
+            <a:schemeClr val="lt1"/>
+          </a:fontRef>
+        </p:style>
+        <p:txBody>
+          <a:bodyPr rtlCol="0" anchor="ctr"/>
+          <a:lstStyle/>
+          <a:p>
+            <a:pPr algn="ctr"/>
+          </a:p>
+        </p:txBody>
+      </p:sp>
+      <p:sp>
+        <p:nvSpPr>
+          <p:cNvPr id="45" name="TextBox 44"/>
+          <p:cNvSpPr txBox="1"/>
+          <p:nvPr/>
+        </p:nvSpPr>
+        <p:spPr>
+          <a:xfrm>
+            <a:off x="4325112" y="6784848"/>
+            <a:ext cx="2642616" cy="438912"/>
+          </a:xfrm>
+          <a:prstGeom prst="rect">
+            <a:avLst/>
+          </a:prstGeom>
+          <a:noFill/>
+        </p:spPr>
+        <p:txBody>
+          <a:bodyPr wrap="square" lIns="0" rIns="0" tIns="0" bIns="0" anchor="ctr">
+            <a:noAutofit/>
+          </a:bodyPr>
+          <a:lstStyle/>
+          <a:p>
+            <a:pPr algn="ctr">
+              <a:lnSpc>
+                <a:spcPct val="100000"/>
+              </a:lnSpc>
+              <a:spcBef>
+                <a:spcPts val="0"/>
+              </a:spcBef>
+              <a:spcAft>
+                <a:spcPts val="0"/>
+              </a:spcAft>
+            </a:pPr>
+            <a:r>
+              <a:rPr sz="1350" b="0" i="0">
+                <a:solidFill>
+                  <a:srgbClr val="6D28D9"/>
+                </a:solidFill>
+                <a:latin typeface="Montserrat SemiBold"/>
+              </a:rPr>
+              <a:t>Extract bids</a:t>
+            </a:r>
+          </a:p>
+        </p:txBody>
+      </p:sp>
+      <p:sp>
+        <p:nvSpPr>
+          <p:cNvPr id="46" name="Rounded Rectangle 45"/>
+          <p:cNvSpPr/>
+          <p:nvPr/>
+        </p:nvSpPr>
+        <p:spPr>
+          <a:xfrm>
+            <a:off x="4325112" y="7516368"/>
+            <a:ext cx="2642616" cy="420624"/>
+          </a:xfrm>
+          <a:prstGeom prst="roundRect">
+            <a:avLst>
+              <a:gd name="adj" fmla="val 50000"/>
             </a:avLst>
           </a:prstGeom>
           <a:solidFill>
@@ -9454,14 +9694,14 @@
       </p:sp>
       <p:sp>
         <p:nvSpPr>
-          <p:cNvPr id="43" name="TextBox 42"/>
-          <p:cNvSpPr txBox="1"/>
-          <p:nvPr/>
-        </p:nvSpPr>
-        <p:spPr>
-          <a:xfrm>
-            <a:off x="4288536" y="8531352"/>
-            <a:ext cx="2715768" cy="329184"/>
+          <p:cNvPr id="47" name="TextBox 46"/>
+          <p:cNvSpPr txBox="1"/>
+          <p:nvPr/>
+        </p:nvSpPr>
+        <p:spPr>
+          <a:xfrm>
+            <a:off x="4325112" y="7516368"/>
+            <a:ext cx="2642616" cy="420624"/>
           </a:xfrm>
           <a:prstGeom prst="rect">
             <a:avLst/>
@@ -9486,7 +9726,7 @@
               </a:spcAft>
             </a:pPr>
             <a:r>
-              <a:rPr sz="1100" b="1" i="0" spc="80">
+              <a:rPr sz="1100" b="0" i="0" spc="80">
                 <a:solidFill>
                   <a:srgbClr val="146B3F"/>
                 </a:solidFill>
@@ -9499,14 +9739,14 @@
       </p:sp>
       <p:sp>
         <p:nvSpPr>
-          <p:cNvPr id="44" name="Rounded Rectangle 43"/>
+          <p:cNvPr id="48" name="Rounded Rectangle 47"/>
           <p:cNvSpPr/>
           <p:nvPr/>
         </p:nvSpPr>
         <p:spPr>
           <a:xfrm>
-            <a:off x="7379208" y="3246120"/>
-            <a:ext cx="3154680" cy="5806440"/>
+            <a:off x="7379208" y="3291840"/>
+            <a:ext cx="3154680" cy="4892040"/>
           </a:xfrm>
           <a:prstGeom prst="roundRect">
             <a:avLst>
@@ -9547,13 +9787,13 @@
       </p:sp>
       <p:sp>
         <p:nvSpPr>
-          <p:cNvPr id="45" name="Rectangle 44"/>
+          <p:cNvPr id="49" name="Rectangle 48"/>
           <p:cNvSpPr/>
           <p:nvPr/>
         </p:nvSpPr>
         <p:spPr>
           <a:xfrm>
-            <a:off x="7379208" y="3246120"/>
+            <a:off x="7379208" y="3291840"/>
             <a:ext cx="3154680" cy="64008"/>
           </a:xfrm>
           <a:prstGeom prst="rect">
@@ -9591,18 +9831,18 @@
       </p:sp>
       <p:sp>
         <p:nvSpPr>
-          <p:cNvPr id="46" name="Rounded Rectangle 45"/>
+          <p:cNvPr id="50" name="Rounded Rectangle 49"/>
           <p:cNvSpPr/>
           <p:nvPr/>
         </p:nvSpPr>
         <p:spPr>
           <a:xfrm>
-            <a:off x="7598664" y="3538727"/>
-            <a:ext cx="603504" cy="603504"/>
+            <a:off x="7635240" y="3602736"/>
+            <a:ext cx="658368" cy="658368"/>
           </a:xfrm>
           <a:prstGeom prst="roundRect">
             <a:avLst>
-              <a:gd name="adj" fmla="val 18181"/>
+              <a:gd name="adj" fmla="val 19444"/>
             </a:avLst>
           </a:prstGeom>
           <a:solidFill>
@@ -9637,7 +9877,7 @@
       </p:sp>
       <p:pic>
         <p:nvPicPr>
-          <p:cNvPr id="47" name="Picture 46" descr="icon_negotiation_purple.png"/>
+          <p:cNvPr id="51" name="Picture 50" descr="icon_negotiation_purple.png"/>
           <p:cNvPicPr>
             <a:picLocks noChangeAspect="1"/>
           </p:cNvPicPr>
@@ -9651,7 +9891,7 @@
         </p:blipFill>
         <p:spPr>
           <a:xfrm>
-            <a:off x="7717536" y="3657600"/>
+            <a:off x="7781544" y="3749039"/>
             <a:ext cx="365760" cy="365760"/>
           </a:xfrm>
           <a:prstGeom prst="rect">
@@ -9661,14 +9901,14 @@
       </p:pic>
       <p:sp>
         <p:nvSpPr>
-          <p:cNvPr id="48" name="TextBox 47"/>
-          <p:cNvSpPr txBox="1"/>
-          <p:nvPr/>
-        </p:nvSpPr>
-        <p:spPr>
-          <a:xfrm>
-            <a:off x="8311896" y="3557015"/>
-            <a:ext cx="2020824" cy="566928"/>
+          <p:cNvPr id="52" name="TextBox 51"/>
+          <p:cNvSpPr txBox="1"/>
+          <p:nvPr/>
+        </p:nvSpPr>
+        <p:spPr>
+          <a:xfrm>
+            <a:off x="8458200" y="3602736"/>
+            <a:ext cx="1819656" cy="658368"/>
           </a:xfrm>
           <a:prstGeom prst="rect">
             <a:avLst/>
@@ -9706,14 +9946,14 @@
       </p:sp>
       <p:sp>
         <p:nvSpPr>
-          <p:cNvPr id="49" name="TextBox 48"/>
-          <p:cNvSpPr txBox="1"/>
-          <p:nvPr/>
-        </p:nvSpPr>
-        <p:spPr>
-          <a:xfrm>
-            <a:off x="7598664" y="4297679"/>
-            <a:ext cx="2715768" cy="457200"/>
+          <p:cNvPr id="53" name="TextBox 52"/>
+          <p:cNvSpPr txBox="1"/>
+          <p:nvPr/>
+        </p:nvSpPr>
+        <p:spPr>
+          <a:xfrm>
+            <a:off x="7635240" y="4480560"/>
+            <a:ext cx="2642616" cy="502920"/>
           </a:xfrm>
           <a:prstGeom prst="rect">
             <a:avLst/>
@@ -9738,27 +9978,27 @@
               </a:spcAft>
             </a:pPr>
             <a:r>
-              <a:rPr sz="2000" b="0" i="0">
+              <a:rPr sz="2500" b="0" i="0">
                 <a:solidFill>
                   <a:srgbClr val="1B1F26"/>
                 </a:solidFill>
                 <a:latin typeface="Montserrat Medium"/>
               </a:rPr>
-              <a:t>Negotiation Agent</a:t>
-            </a:r>
-          </a:p>
-        </p:txBody>
-      </p:sp>
-      <p:sp>
-        <p:nvSpPr>
-          <p:cNvPr id="50" name="TextBox 49"/>
-          <p:cNvSpPr txBox="1"/>
-          <p:nvPr/>
-        </p:nvSpPr>
-        <p:spPr>
-          <a:xfrm>
-            <a:off x="7598664" y="4818888"/>
-            <a:ext cx="2715768" cy="1097280"/>
+              <a:t>Negotiation</a:t>
+            </a:r>
+          </a:p>
+        </p:txBody>
+      </p:sp>
+      <p:sp>
+        <p:nvSpPr>
+          <p:cNvPr id="54" name="TextBox 53"/>
+          <p:cNvSpPr txBox="1"/>
+          <p:nvPr/>
+        </p:nvSpPr>
+        <p:spPr>
+          <a:xfrm>
+            <a:off x="7635240" y="5120640"/>
+            <a:ext cx="2642616" cy="365760"/>
           </a:xfrm>
           <a:prstGeom prst="rect">
             <a:avLst/>
@@ -9773,86 +10013,96 @@
           <a:p>
             <a:pPr algn="l">
               <a:lnSpc>
-                <a:spcPct val="120000"/>
-              </a:lnSpc>
-              <a:spcBef>
-                <a:spcPts val="0"/>
-              </a:spcBef>
-              <a:spcAft>
-                <a:spcPts val="0"/>
-              </a:spcAft>
-            </a:pPr>
-            <a:r>
-              <a:rPr sz="1300" b="0" i="0">
-                <a:solidFill>
-                  <a:srgbClr val="6A707B"/>
-                </a:solidFill>
-                <a:latin typeface="Montserrat"/>
-              </a:rPr>
-              <a:t>Multi-parameter, asynchronous negotiation across price, terms &amp; lead time.</a:t>
-            </a:r>
-          </a:p>
-        </p:txBody>
-      </p:sp>
-      <p:cxnSp>
-        <p:nvCxnSpPr>
-          <p:cNvPr id="51" name="Connector 50"/>
-          <p:cNvCxnSpPr/>
-          <p:nvPr/>
-        </p:nvCxnSpPr>
-        <p:spPr>
-          <a:xfrm>
-            <a:off x="7598664" y="6035040"/>
-            <a:ext cx="2715768" cy="0"/>
-          </a:xfrm>
-          <a:prstGeom prst="bentConnector3">
-            <a:avLst/>
-          </a:prstGeom>
-          <a:ln w="9525">
-            <a:solidFill>
-              <a:srgbClr val="E2E4EA"/>
-            </a:solidFill>
+                <a:spcPct val="100000"/>
+              </a:lnSpc>
+              <a:spcBef>
+                <a:spcPts val="0"/>
+              </a:spcBef>
+              <a:spcAft>
+                <a:spcPts val="0"/>
+              </a:spcAft>
+            </a:pPr>
+            <a:r>
+              <a:rPr sz="1400" b="0" i="0">
+                <a:solidFill>
+                  <a:srgbClr val="7C3AED"/>
+                </a:solidFill>
+                <a:latin typeface="Montserrat Medium"/>
+              </a:rPr>
+              <a:t>AI Negotiation</a:t>
+            </a:r>
+          </a:p>
+        </p:txBody>
+      </p:sp>
+      <p:sp>
+        <p:nvSpPr>
+          <p:cNvPr id="55" name="Rounded Rectangle 54"/>
+          <p:cNvSpPr/>
+          <p:nvPr/>
+        </p:nvSpPr>
+        <p:spPr>
+          <a:xfrm>
+            <a:off x="7635240" y="5687568"/>
+            <a:ext cx="2642616" cy="438912"/>
+          </a:xfrm>
+          <a:prstGeom prst="roundRect">
+            <a:avLst>
+              <a:gd name="adj" fmla="val 50000"/>
+            </a:avLst>
+          </a:prstGeom>
+          <a:solidFill>
+            <a:srgbClr val="F1EAFC"/>
+          </a:solidFill>
+          <a:ln>
+            <a:noFill/>
           </a:ln>
           <a:effectLst/>
         </p:spPr>
         <p:style>
-          <a:lnRef idx="2">
+          <a:lnRef idx="1">
             <a:schemeClr val="accent1"/>
           </a:lnRef>
-          <a:fillRef idx="0">
+          <a:fillRef idx="3">
             <a:schemeClr val="accent1"/>
           </a:fillRef>
-          <a:effectRef idx="1">
+          <a:effectRef idx="2">
             <a:schemeClr val="accent1"/>
           </a:effectRef>
           <a:fontRef idx="minor">
-            <a:schemeClr val="tx1"/>
+            <a:schemeClr val="lt1"/>
           </a:fontRef>
         </p:style>
-      </p:cxnSp>
-      <p:sp>
-        <p:nvSpPr>
-          <p:cNvPr id="52" name="TextBox 51"/>
-          <p:cNvSpPr txBox="1"/>
-          <p:nvPr/>
-        </p:nvSpPr>
-        <p:spPr>
-          <a:xfrm>
-            <a:off x="7598664" y="6190488"/>
-            <a:ext cx="2715768" cy="182880"/>
-          </a:xfrm>
-          <a:prstGeom prst="rect">
-            <a:avLst/>
-          </a:prstGeom>
-          <a:noFill/>
-        </p:spPr>
-        <p:txBody>
-          <a:bodyPr wrap="square" lIns="0" rIns="0" tIns="0" bIns="0" anchor="t">
-            <a:noAutofit/>
-          </a:bodyPr>
-          <a:lstStyle/>
-          <a:p>
-            <a:pPr algn="l">
+        <p:txBody>
+          <a:bodyPr rtlCol="0" anchor="ctr"/>
+          <a:lstStyle/>
+          <a:p>
+            <a:pPr algn="ctr"/>
+          </a:p>
+        </p:txBody>
+      </p:sp>
+      <p:sp>
+        <p:nvSpPr>
+          <p:cNvPr id="56" name="TextBox 55"/>
+          <p:cNvSpPr txBox="1"/>
+          <p:nvPr/>
+        </p:nvSpPr>
+        <p:spPr>
+          <a:xfrm>
+            <a:off x="7635240" y="5687568"/>
+            <a:ext cx="2642616" cy="438912"/>
+          </a:xfrm>
+          <a:prstGeom prst="rect">
+            <a:avLst/>
+          </a:prstGeom>
+          <a:noFill/>
+        </p:spPr>
+        <p:txBody>
+          <a:bodyPr wrap="square" lIns="0" rIns="0" tIns="0" bIns="0" anchor="ctr">
+            <a:noAutofit/>
+          </a:bodyPr>
+          <a:lstStyle/>
+          <a:p>
+            <a:pPr algn="ctr">
               <a:lnSpc>
                 <a:spcPct val="100000"/>
               </a:lnSpc>
@@ -9864,121 +10114,213 @@
               </a:spcAft>
             </a:pPr>
             <a:r>
-              <a:rPr sz="950" b="1" i="0" spc="60">
-                <a:solidFill>
-                  <a:srgbClr val="6A707B"/>
-                </a:solidFill>
-                <a:latin typeface="Consolas"/>
-              </a:rPr>
-              <a:t>↓ AERCHAIN CAPABILITY</a:t>
-            </a:r>
-          </a:p>
-        </p:txBody>
-      </p:sp>
-      <p:sp>
-        <p:nvSpPr>
-          <p:cNvPr id="53" name="TextBox 52"/>
-          <p:cNvSpPr txBox="1"/>
-          <p:nvPr/>
-        </p:nvSpPr>
-        <p:spPr>
-          <a:xfrm>
-            <a:off x="7598664" y="6446520"/>
-            <a:ext cx="2715768" cy="548640"/>
-          </a:xfrm>
-          <a:prstGeom prst="rect">
-            <a:avLst/>
-          </a:prstGeom>
-          <a:noFill/>
-        </p:spPr>
-        <p:txBody>
-          <a:bodyPr wrap="square" lIns="0" rIns="0" tIns="0" bIns="0" anchor="t">
-            <a:noAutofit/>
-          </a:bodyPr>
-          <a:lstStyle/>
-          <a:p>
-            <a:pPr algn="l">
-              <a:lnSpc>
-                <a:spcPct val="105000"/>
-              </a:lnSpc>
-              <a:spcBef>
-                <a:spcPts val="0"/>
-              </a:spcBef>
-              <a:spcAft>
-                <a:spcPts val="0"/>
-              </a:spcAft>
-            </a:pPr>
-            <a:r>
-              <a:rPr sz="1500" b="0" i="0">
-                <a:solidFill>
-                  <a:srgbClr val="7C3AED"/>
-                </a:solidFill>
-                <a:latin typeface="Montserrat Medium"/>
-              </a:rPr>
-              <a:t>AI Negotiation</a:t>
-            </a:r>
-          </a:p>
-        </p:txBody>
-      </p:sp>
-      <p:sp>
-        <p:nvSpPr>
-          <p:cNvPr id="54" name="TextBox 53"/>
-          <p:cNvSpPr txBox="1"/>
-          <p:nvPr/>
-        </p:nvSpPr>
-        <p:spPr>
-          <a:xfrm>
-            <a:off x="7598664" y="7104888"/>
-            <a:ext cx="2715768" cy="1371600"/>
-          </a:xfrm>
-          <a:prstGeom prst="rect">
-            <a:avLst/>
-          </a:prstGeom>
-          <a:noFill/>
-        </p:spPr>
-        <p:txBody>
-          <a:bodyPr wrap="square" lIns="0" rIns="0" tIns="0" bIns="0" anchor="t">
-            <a:noAutofit/>
-          </a:bodyPr>
-          <a:lstStyle/>
-          <a:p>
-            <a:pPr algn="l">
-              <a:lnSpc>
-                <a:spcPct val="122000"/>
-              </a:lnSpc>
-              <a:spcBef>
-                <a:spcPts val="0"/>
-              </a:spcBef>
-              <a:spcAft>
-                <a:spcPts val="0"/>
-              </a:spcAft>
-            </a:pPr>
-            <a:r>
-              <a:rPr sz="1200" b="0" i="0">
-                <a:solidFill>
-                  <a:srgbClr val="484E59"/>
-                </a:solidFill>
-                <a:latin typeface="Montserrat"/>
-              </a:rPr>
-              <a:t>Multi-round, configurable-autonomy negotiations with price loading and total-cost normalisation across regions.</a:t>
-            </a:r>
-          </a:p>
-        </p:txBody>
-      </p:sp>
-      <p:sp>
-        <p:nvSpPr>
-          <p:cNvPr id="55" name="Rounded Rectangle 54"/>
+              <a:rPr sz="1350" b="0" i="0">
+                <a:solidFill>
+                  <a:srgbClr val="6D28D9"/>
+                </a:solidFill>
+                <a:latin typeface="Montserrat SemiBold"/>
+              </a:rPr>
+              <a:t>Multi-round</a:t>
+            </a:r>
+          </a:p>
+        </p:txBody>
+      </p:sp>
+      <p:sp>
+        <p:nvSpPr>
+          <p:cNvPr id="57" name="Rounded Rectangle 56"/>
           <p:cNvSpPr/>
           <p:nvPr/>
         </p:nvSpPr>
         <p:spPr>
           <a:xfrm>
-            <a:off x="7598664" y="8531352"/>
-            <a:ext cx="2715768" cy="329184"/>
+            <a:off x="7635240" y="6236208"/>
+            <a:ext cx="2642616" cy="438912"/>
           </a:xfrm>
           <a:prstGeom prst="roundRect">
             <a:avLst>
-              <a:gd name="adj" fmla="val 13888"/>
+              <a:gd name="adj" fmla="val 50000"/>
+            </a:avLst>
+          </a:prstGeom>
+          <a:solidFill>
+            <a:srgbClr val="F1EAFC"/>
+          </a:solidFill>
+          <a:ln>
+            <a:noFill/>
+          </a:ln>
+          <a:effectLst/>
+        </p:spPr>
+        <p:style>
+          <a:lnRef idx="1">
+            <a:schemeClr val="accent1"/>
+          </a:lnRef>
+          <a:fillRef idx="3">
+            <a:schemeClr val="accent1"/>
+          </a:fillRef>
+          <a:effectRef idx="2">
+            <a:schemeClr val="accent1"/>
+          </a:effectRef>
+          <a:fontRef idx="minor">
+            <a:schemeClr val="lt1"/>
+          </a:fontRef>
+        </p:style>
+        <p:txBody>
+          <a:bodyPr rtlCol="0" anchor="ctr"/>
+          <a:lstStyle/>
+          <a:p>
+            <a:pPr algn="ctr"/>
+          </a:p>
+        </p:txBody>
+      </p:sp>
+      <p:sp>
+        <p:nvSpPr>
+          <p:cNvPr id="58" name="TextBox 57"/>
+          <p:cNvSpPr txBox="1"/>
+          <p:nvPr/>
+        </p:nvSpPr>
+        <p:spPr>
+          <a:xfrm>
+            <a:off x="7635240" y="6236208"/>
+            <a:ext cx="2642616" cy="438912"/>
+          </a:xfrm>
+          <a:prstGeom prst="rect">
+            <a:avLst/>
+          </a:prstGeom>
+          <a:noFill/>
+        </p:spPr>
+        <p:txBody>
+          <a:bodyPr wrap="square" lIns="0" rIns="0" tIns="0" bIns="0" anchor="ctr">
+            <a:noAutofit/>
+          </a:bodyPr>
+          <a:lstStyle/>
+          <a:p>
+            <a:pPr algn="ctr">
+              <a:lnSpc>
+                <a:spcPct val="100000"/>
+              </a:lnSpc>
+              <a:spcBef>
+                <a:spcPts val="0"/>
+              </a:spcBef>
+              <a:spcAft>
+                <a:spcPts val="0"/>
+              </a:spcAft>
+            </a:pPr>
+            <a:r>
+              <a:rPr sz="1350" b="0" i="0">
+                <a:solidFill>
+                  <a:srgbClr val="6D28D9"/>
+                </a:solidFill>
+                <a:latin typeface="Montserrat SemiBold"/>
+              </a:rPr>
+              <a:t>Price &amp; terms</a:t>
+            </a:r>
+          </a:p>
+        </p:txBody>
+      </p:sp>
+      <p:sp>
+        <p:nvSpPr>
+          <p:cNvPr id="59" name="Rounded Rectangle 58"/>
+          <p:cNvSpPr/>
+          <p:nvPr/>
+        </p:nvSpPr>
+        <p:spPr>
+          <a:xfrm>
+            <a:off x="7635240" y="6784848"/>
+            <a:ext cx="2642616" cy="438912"/>
+          </a:xfrm>
+          <a:prstGeom prst="roundRect">
+            <a:avLst>
+              <a:gd name="adj" fmla="val 50000"/>
+            </a:avLst>
+          </a:prstGeom>
+          <a:solidFill>
+            <a:srgbClr val="F1EAFC"/>
+          </a:solidFill>
+          <a:ln>
+            <a:noFill/>
+          </a:ln>
+          <a:effectLst/>
+        </p:spPr>
+        <p:style>
+          <a:lnRef idx="1">
+            <a:schemeClr val="accent1"/>
+          </a:lnRef>
+          <a:fillRef idx="3">
+            <a:schemeClr val="accent1"/>
+          </a:fillRef>
+          <a:effectRef idx="2">
+            <a:schemeClr val="accent1"/>
+          </a:effectRef>
+          <a:fontRef idx="minor">
+            <a:schemeClr val="lt1"/>
+          </a:fontRef>
+        </p:style>
+        <p:txBody>
+          <a:bodyPr rtlCol="0" anchor="ctr"/>
+          <a:lstStyle/>
+          <a:p>
+            <a:pPr algn="ctr"/>
+          </a:p>
+        </p:txBody>
+      </p:sp>
+      <p:sp>
+        <p:nvSpPr>
+          <p:cNvPr id="60" name="TextBox 59"/>
+          <p:cNvSpPr txBox="1"/>
+          <p:nvPr/>
+        </p:nvSpPr>
+        <p:spPr>
+          <a:xfrm>
+            <a:off x="7635240" y="6784848"/>
+            <a:ext cx="2642616" cy="438912"/>
+          </a:xfrm>
+          <a:prstGeom prst="rect">
+            <a:avLst/>
+          </a:prstGeom>
+          <a:noFill/>
+        </p:spPr>
+        <p:txBody>
+          <a:bodyPr wrap="square" lIns="0" rIns="0" tIns="0" bIns="0" anchor="ctr">
+            <a:noAutofit/>
+          </a:bodyPr>
+          <a:lstStyle/>
+          <a:p>
+            <a:pPr algn="ctr">
+              <a:lnSpc>
+                <a:spcPct val="100000"/>
+              </a:lnSpc>
+              <a:spcBef>
+                <a:spcPts val="0"/>
+              </a:spcBef>
+              <a:spcAft>
+                <a:spcPts val="0"/>
+              </a:spcAft>
+            </a:pPr>
+            <a:r>
+              <a:rPr sz="1350" b="0" i="0">
+                <a:solidFill>
+                  <a:srgbClr val="6D28D9"/>
+                </a:solidFill>
+                <a:latin typeface="Montserrat SemiBold"/>
+              </a:rPr>
+              <a:t>Auto-negotiate</a:t>
+            </a:r>
+          </a:p>
+        </p:txBody>
+      </p:sp>
+      <p:sp>
+        <p:nvSpPr>
+          <p:cNvPr id="61" name="Rounded Rectangle 60"/>
+          <p:cNvSpPr/>
+          <p:nvPr/>
+        </p:nvSpPr>
+        <p:spPr>
+          <a:xfrm>
+            <a:off x="7635240" y="7516368"/>
+            <a:ext cx="2642616" cy="420624"/>
+          </a:xfrm>
+          <a:prstGeom prst="roundRect">
+            <a:avLst>
+              <a:gd name="adj" fmla="val 50000"/>
             </a:avLst>
           </a:prstGeom>
           <a:solidFill>
@@ -10015,14 +10357,14 @@
       </p:sp>
       <p:sp>
         <p:nvSpPr>
-          <p:cNvPr id="56" name="TextBox 55"/>
-          <p:cNvSpPr txBox="1"/>
-          <p:nvPr/>
-        </p:nvSpPr>
-        <p:spPr>
-          <a:xfrm>
-            <a:off x="7598664" y="8531352"/>
-            <a:ext cx="2715768" cy="329184"/>
+          <p:cNvPr id="62" name="TextBox 61"/>
+          <p:cNvSpPr txBox="1"/>
+          <p:nvPr/>
+        </p:nvSpPr>
+        <p:spPr>
+          <a:xfrm>
+            <a:off x="7635240" y="7516368"/>
+            <a:ext cx="2642616" cy="420624"/>
           </a:xfrm>
           <a:prstGeom prst="rect">
             <a:avLst/>
@@ -10047,7 +10389,7 @@
               </a:spcAft>
             </a:pPr>
             <a:r>
-              <a:rPr sz="1100" b="1" i="0" spc="80">
+              <a:rPr sz="1100" b="0" i="0" spc="80">
                 <a:solidFill>
                   <a:srgbClr val="146B3F"/>
                 </a:solidFill>
@@ -10060,14 +10402,14 @@
       </p:sp>
       <p:sp>
         <p:nvSpPr>
-          <p:cNvPr id="57" name="Rounded Rectangle 56"/>
+          <p:cNvPr id="63" name="Rounded Rectangle 62"/>
           <p:cNvSpPr/>
           <p:nvPr/>
         </p:nvSpPr>
         <p:spPr>
           <a:xfrm>
-            <a:off x="10689336" y="3246120"/>
-            <a:ext cx="3154680" cy="5806440"/>
+            <a:off x="10689336" y="3291840"/>
+            <a:ext cx="3154680" cy="4892040"/>
           </a:xfrm>
           <a:prstGeom prst="roundRect">
             <a:avLst>
@@ -10108,13 +10450,13 @@
       </p:sp>
       <p:sp>
         <p:nvSpPr>
-          <p:cNvPr id="58" name="Rectangle 57"/>
+          <p:cNvPr id="64" name="Rectangle 63"/>
           <p:cNvSpPr/>
           <p:nvPr/>
         </p:nvSpPr>
         <p:spPr>
           <a:xfrm>
-            <a:off x="10689336" y="3246120"/>
+            <a:off x="10689336" y="3291840"/>
             <a:ext cx="3154680" cy="64008"/>
           </a:xfrm>
           <a:prstGeom prst="rect">
@@ -10152,18 +10494,18 @@
       </p:sp>
       <p:sp>
         <p:nvSpPr>
-          <p:cNvPr id="59" name="Rounded Rectangle 58"/>
+          <p:cNvPr id="65" name="Rounded Rectangle 64"/>
           <p:cNvSpPr/>
           <p:nvPr/>
         </p:nvSpPr>
         <p:spPr>
           <a:xfrm>
-            <a:off x="10908792" y="3538727"/>
-            <a:ext cx="603504" cy="603504"/>
+            <a:off x="10945367" y="3602736"/>
+            <a:ext cx="658368" cy="658368"/>
           </a:xfrm>
           <a:prstGeom prst="roundRect">
             <a:avLst>
-              <a:gd name="adj" fmla="val 18181"/>
+              <a:gd name="adj" fmla="val 19444"/>
             </a:avLst>
           </a:prstGeom>
           <a:solidFill>
@@ -10198,7 +10540,7 @@
       </p:sp>
       <p:pic>
         <p:nvPicPr>
-          <p:cNvPr id="60" name="Picture 59" descr="icon_evaluation_purple.png"/>
+          <p:cNvPr id="66" name="Picture 65" descr="icon_evaluation_purple.png"/>
           <p:cNvPicPr>
             <a:picLocks noChangeAspect="1"/>
           </p:cNvPicPr>
@@ -10212,7 +10554,7 @@
         </p:blipFill>
         <p:spPr>
           <a:xfrm>
-            <a:off x="11027663" y="3657600"/>
+            <a:off x="11091672" y="3749039"/>
             <a:ext cx="365760" cy="365760"/>
           </a:xfrm>
           <a:prstGeom prst="rect">
@@ -10222,14 +10564,14 @@
       </p:pic>
       <p:sp>
         <p:nvSpPr>
-          <p:cNvPr id="61" name="TextBox 60"/>
-          <p:cNvSpPr txBox="1"/>
-          <p:nvPr/>
-        </p:nvSpPr>
-        <p:spPr>
-          <a:xfrm>
-            <a:off x="11622024" y="3557015"/>
-            <a:ext cx="2020824" cy="566928"/>
+          <p:cNvPr id="67" name="TextBox 66"/>
+          <p:cNvSpPr txBox="1"/>
+          <p:nvPr/>
+        </p:nvSpPr>
+        <p:spPr>
+          <a:xfrm>
+            <a:off x="11768328" y="3602736"/>
+            <a:ext cx="1819656" cy="658368"/>
           </a:xfrm>
           <a:prstGeom prst="rect">
             <a:avLst/>
@@ -10267,14 +10609,14 @@
       </p:sp>
       <p:sp>
         <p:nvSpPr>
-          <p:cNvPr id="62" name="TextBox 61"/>
-          <p:cNvSpPr txBox="1"/>
-          <p:nvPr/>
-        </p:nvSpPr>
-        <p:spPr>
-          <a:xfrm>
-            <a:off x="10908792" y="4297679"/>
-            <a:ext cx="2715768" cy="457200"/>
+          <p:cNvPr id="68" name="TextBox 67"/>
+          <p:cNvSpPr txBox="1"/>
+          <p:nvPr/>
+        </p:nvSpPr>
+        <p:spPr>
+          <a:xfrm>
+            <a:off x="10945367" y="4480560"/>
+            <a:ext cx="2642616" cy="502920"/>
           </a:xfrm>
           <a:prstGeom prst="rect">
             <a:avLst/>
@@ -10299,27 +10641,27 @@
               </a:spcAft>
             </a:pPr>
             <a:r>
-              <a:rPr sz="2000" b="0" i="0">
+              <a:rPr sz="2500" b="0" i="0">
                 <a:solidFill>
                   <a:srgbClr val="1B1F26"/>
                 </a:solidFill>
                 <a:latin typeface="Montserrat Medium"/>
               </a:rPr>
-              <a:t>Evaluation Agent</a:t>
-            </a:r>
-          </a:p>
-        </p:txBody>
-      </p:sp>
-      <p:sp>
-        <p:nvSpPr>
-          <p:cNvPr id="63" name="TextBox 62"/>
-          <p:cNvSpPr txBox="1"/>
-          <p:nvPr/>
-        </p:nvSpPr>
-        <p:spPr>
-          <a:xfrm>
-            <a:off x="10908792" y="4818888"/>
-            <a:ext cx="2715768" cy="1097280"/>
+              <a:t>Evaluation</a:t>
+            </a:r>
+          </a:p>
+        </p:txBody>
+      </p:sp>
+      <p:sp>
+        <p:nvSpPr>
+          <p:cNvPr id="69" name="TextBox 68"/>
+          <p:cNvSpPr txBox="1"/>
+          <p:nvPr/>
+        </p:nvSpPr>
+        <p:spPr>
+          <a:xfrm>
+            <a:off x="10945367" y="5120640"/>
+            <a:ext cx="2642616" cy="365760"/>
           </a:xfrm>
           <a:prstGeom prst="rect">
             <a:avLst/>
@@ -10334,86 +10676,96 @@
           <a:p>
             <a:pPr algn="l">
               <a:lnSpc>
-                <a:spcPct val="120000"/>
-              </a:lnSpc>
-              <a:spcBef>
-                <a:spcPts val="0"/>
-              </a:spcBef>
-              <a:spcAft>
-                <a:spcPts val="0"/>
-              </a:spcAft>
-            </a:pPr>
-            <a:r>
-              <a:rPr sz="1300" b="0" i="0">
-                <a:solidFill>
-                  <a:srgbClr val="6A707B"/>
-                </a:solidFill>
-                <a:latin typeface="Montserrat"/>
-              </a:rPr>
-              <a:t>Scores every bid; runs compliance and risk checks silently in the background.</a:t>
-            </a:r>
-          </a:p>
-        </p:txBody>
-      </p:sp>
-      <p:cxnSp>
-        <p:nvCxnSpPr>
-          <p:cNvPr id="64" name="Connector 63"/>
-          <p:cNvCxnSpPr/>
-          <p:nvPr/>
-        </p:nvCxnSpPr>
-        <p:spPr>
-          <a:xfrm>
-            <a:off x="10908792" y="6035040"/>
-            <a:ext cx="2715768" cy="0"/>
-          </a:xfrm>
-          <a:prstGeom prst="bentConnector3">
-            <a:avLst/>
-          </a:prstGeom>
-          <a:ln w="9525">
-            <a:solidFill>
-              <a:srgbClr val="E2E4EA"/>
-            </a:solidFill>
+                <a:spcPct val="100000"/>
+              </a:lnSpc>
+              <a:spcBef>
+                <a:spcPts val="0"/>
+              </a:spcBef>
+              <a:spcAft>
+                <a:spcPts val="0"/>
+              </a:spcAft>
+            </a:pPr>
+            <a:r>
+              <a:rPr sz="1400" b="0" i="0">
+                <a:solidFill>
+                  <a:srgbClr val="7C3AED"/>
+                </a:solidFill>
+                <a:latin typeface="Montserrat Medium"/>
+              </a:rPr>
+              <a:t>Eval + Compliance</a:t>
+            </a:r>
+          </a:p>
+        </p:txBody>
+      </p:sp>
+      <p:sp>
+        <p:nvSpPr>
+          <p:cNvPr id="70" name="Rounded Rectangle 69"/>
+          <p:cNvSpPr/>
+          <p:nvPr/>
+        </p:nvSpPr>
+        <p:spPr>
+          <a:xfrm>
+            <a:off x="10945367" y="5687568"/>
+            <a:ext cx="2642616" cy="438912"/>
+          </a:xfrm>
+          <a:prstGeom prst="roundRect">
+            <a:avLst>
+              <a:gd name="adj" fmla="val 50000"/>
+            </a:avLst>
+          </a:prstGeom>
+          <a:solidFill>
+            <a:srgbClr val="F1EAFC"/>
+          </a:solidFill>
+          <a:ln>
+            <a:noFill/>
           </a:ln>
           <a:effectLst/>
         </p:spPr>
         <p:style>
-          <a:lnRef idx="2">
+          <a:lnRef idx="1">
             <a:schemeClr val="accent1"/>
           </a:lnRef>
-          <a:fillRef idx="0">
+          <a:fillRef idx="3">
             <a:schemeClr val="accent1"/>
           </a:fillRef>
-          <a:effectRef idx="1">
+          <a:effectRef idx="2">
             <a:schemeClr val="accent1"/>
           </a:effectRef>
           <a:fontRef idx="minor">
-            <a:schemeClr val="tx1"/>
+            <a:schemeClr val="lt1"/>
           </a:fontRef>
         </p:style>
-      </p:cxnSp>
-      <p:sp>
-        <p:nvSpPr>
-          <p:cNvPr id="65" name="TextBox 64"/>
-          <p:cNvSpPr txBox="1"/>
-          <p:nvPr/>
-        </p:nvSpPr>
-        <p:spPr>
-          <a:xfrm>
-            <a:off x="10908792" y="6190488"/>
-            <a:ext cx="2715768" cy="182880"/>
-          </a:xfrm>
-          <a:prstGeom prst="rect">
-            <a:avLst/>
-          </a:prstGeom>
-          <a:noFill/>
-        </p:spPr>
-        <p:txBody>
-          <a:bodyPr wrap="square" lIns="0" rIns="0" tIns="0" bIns="0" anchor="t">
-            <a:noAutofit/>
-          </a:bodyPr>
-          <a:lstStyle/>
-          <a:p>
-            <a:pPr algn="l">
+        <p:txBody>
+          <a:bodyPr rtlCol="0" anchor="ctr"/>
+          <a:lstStyle/>
+          <a:p>
+            <a:pPr algn="ctr"/>
+          </a:p>
+        </p:txBody>
+      </p:sp>
+      <p:sp>
+        <p:nvSpPr>
+          <p:cNvPr id="71" name="TextBox 70"/>
+          <p:cNvSpPr txBox="1"/>
+          <p:nvPr/>
+        </p:nvSpPr>
+        <p:spPr>
+          <a:xfrm>
+            <a:off x="10945367" y="5687568"/>
+            <a:ext cx="2642616" cy="438912"/>
+          </a:xfrm>
+          <a:prstGeom prst="rect">
+            <a:avLst/>
+          </a:prstGeom>
+          <a:noFill/>
+        </p:spPr>
+        <p:txBody>
+          <a:bodyPr wrap="square" lIns="0" rIns="0" tIns="0" bIns="0" anchor="ctr">
+            <a:noAutofit/>
+          </a:bodyPr>
+          <a:lstStyle/>
+          <a:p>
+            <a:pPr algn="ctr">
               <a:lnSpc>
                 <a:spcPct val="100000"/>
               </a:lnSpc>
@@ -10425,121 +10777,213 @@
               </a:spcAft>
             </a:pPr>
             <a:r>
-              <a:rPr sz="950" b="1" i="0" spc="60">
-                <a:solidFill>
-                  <a:srgbClr val="6A707B"/>
-                </a:solidFill>
-                <a:latin typeface="Consolas"/>
-              </a:rPr>
-              <a:t>↓ AERCHAIN CAPABILITY</a:t>
-            </a:r>
-          </a:p>
-        </p:txBody>
-      </p:sp>
-      <p:sp>
-        <p:nvSpPr>
-          <p:cNvPr id="66" name="TextBox 65"/>
-          <p:cNvSpPr txBox="1"/>
-          <p:nvPr/>
-        </p:nvSpPr>
-        <p:spPr>
-          <a:xfrm>
-            <a:off x="10908792" y="6446520"/>
-            <a:ext cx="2715768" cy="548640"/>
-          </a:xfrm>
-          <a:prstGeom prst="rect">
-            <a:avLst/>
-          </a:prstGeom>
-          <a:noFill/>
-        </p:spPr>
-        <p:txBody>
-          <a:bodyPr wrap="square" lIns="0" rIns="0" tIns="0" bIns="0" anchor="t">
-            <a:noAutofit/>
-          </a:bodyPr>
-          <a:lstStyle/>
-          <a:p>
-            <a:pPr algn="l">
-              <a:lnSpc>
-                <a:spcPct val="105000"/>
-              </a:lnSpc>
-              <a:spcBef>
-                <a:spcPts val="0"/>
-              </a:spcBef>
-              <a:spcAft>
-                <a:spcPts val="0"/>
-              </a:spcAft>
-            </a:pPr>
-            <a:r>
-              <a:rPr sz="1500" b="0" i="0">
-                <a:solidFill>
-                  <a:srgbClr val="7C3AED"/>
-                </a:solidFill>
-                <a:latin typeface="Montserrat Medium"/>
-              </a:rPr>
-              <a:t>Eval + Compliance</a:t>
-            </a:r>
-          </a:p>
-        </p:txBody>
-      </p:sp>
-      <p:sp>
-        <p:nvSpPr>
-          <p:cNvPr id="67" name="TextBox 66"/>
-          <p:cNvSpPr txBox="1"/>
-          <p:nvPr/>
-        </p:nvSpPr>
-        <p:spPr>
-          <a:xfrm>
-            <a:off x="10908792" y="7104888"/>
-            <a:ext cx="2715768" cy="1371600"/>
-          </a:xfrm>
-          <a:prstGeom prst="rect">
-            <a:avLst/>
-          </a:prstGeom>
-          <a:noFill/>
-        </p:spPr>
-        <p:txBody>
-          <a:bodyPr wrap="square" lIns="0" rIns="0" tIns="0" bIns="0" anchor="t">
-            <a:noAutofit/>
-          </a:bodyPr>
-          <a:lstStyle/>
-          <a:p>
-            <a:pPr algn="l">
-              <a:lnSpc>
-                <a:spcPct val="122000"/>
-              </a:lnSpc>
-              <a:spcBef>
-                <a:spcPts val="0"/>
-              </a:spcBef>
-              <a:spcAft>
-                <a:spcPts val="0"/>
-              </a:spcAft>
-            </a:pPr>
-            <a:r>
-              <a:rPr sz="1200" b="0" i="0">
-                <a:solidFill>
-                  <a:srgbClr val="484E59"/>
-                </a:solidFill>
-                <a:latin typeface="Montserrat"/>
-              </a:rPr>
-              <a:t>Configurable scoring per category. Compliance runs as a subroutine — single decision surface, single audit entry.</a:t>
-            </a:r>
-          </a:p>
-        </p:txBody>
-      </p:sp>
-      <p:sp>
-        <p:nvSpPr>
-          <p:cNvPr id="68" name="Rounded Rectangle 67"/>
+              <a:rPr sz="1350" b="0" i="0">
+                <a:solidFill>
+                  <a:srgbClr val="6D28D9"/>
+                </a:solidFill>
+                <a:latin typeface="Montserrat SemiBold"/>
+              </a:rPr>
+              <a:t>Score every bid</a:t>
+            </a:r>
+          </a:p>
+        </p:txBody>
+      </p:sp>
+      <p:sp>
+        <p:nvSpPr>
+          <p:cNvPr id="72" name="Rounded Rectangle 71"/>
           <p:cNvSpPr/>
           <p:nvPr/>
         </p:nvSpPr>
         <p:spPr>
           <a:xfrm>
-            <a:off x="10908792" y="8531352"/>
-            <a:ext cx="2715768" cy="329184"/>
+            <a:off x="10945367" y="6236208"/>
+            <a:ext cx="2642616" cy="438912"/>
           </a:xfrm>
           <a:prstGeom prst="roundRect">
             <a:avLst>
-              <a:gd name="adj" fmla="val 13888"/>
+              <a:gd name="adj" fmla="val 50000"/>
+            </a:avLst>
+          </a:prstGeom>
+          <a:solidFill>
+            <a:srgbClr val="F1EAFC"/>
+          </a:solidFill>
+          <a:ln>
+            <a:noFill/>
+          </a:ln>
+          <a:effectLst/>
+        </p:spPr>
+        <p:style>
+          <a:lnRef idx="1">
+            <a:schemeClr val="accent1"/>
+          </a:lnRef>
+          <a:fillRef idx="3">
+            <a:schemeClr val="accent1"/>
+          </a:fillRef>
+          <a:effectRef idx="2">
+            <a:schemeClr val="accent1"/>
+          </a:effectRef>
+          <a:fontRef idx="minor">
+            <a:schemeClr val="lt1"/>
+          </a:fontRef>
+        </p:style>
+        <p:txBody>
+          <a:bodyPr rtlCol="0" anchor="ctr"/>
+          <a:lstStyle/>
+          <a:p>
+            <a:pPr algn="ctr"/>
+          </a:p>
+        </p:txBody>
+      </p:sp>
+      <p:sp>
+        <p:nvSpPr>
+          <p:cNvPr id="73" name="TextBox 72"/>
+          <p:cNvSpPr txBox="1"/>
+          <p:nvPr/>
+        </p:nvSpPr>
+        <p:spPr>
+          <a:xfrm>
+            <a:off x="10945367" y="6236208"/>
+            <a:ext cx="2642616" cy="438912"/>
+          </a:xfrm>
+          <a:prstGeom prst="rect">
+            <a:avLst/>
+          </a:prstGeom>
+          <a:noFill/>
+        </p:spPr>
+        <p:txBody>
+          <a:bodyPr wrap="square" lIns="0" rIns="0" tIns="0" bIns="0" anchor="ctr">
+            <a:noAutofit/>
+          </a:bodyPr>
+          <a:lstStyle/>
+          <a:p>
+            <a:pPr algn="ctr">
+              <a:lnSpc>
+                <a:spcPct val="100000"/>
+              </a:lnSpc>
+              <a:spcBef>
+                <a:spcPts val="0"/>
+              </a:spcBef>
+              <a:spcAft>
+                <a:spcPts val="0"/>
+              </a:spcAft>
+            </a:pPr>
+            <a:r>
+              <a:rPr sz="1350" b="0" i="0">
+                <a:solidFill>
+                  <a:srgbClr val="6D28D9"/>
+                </a:solidFill>
+                <a:latin typeface="Montserrat SemiBold"/>
+              </a:rPr>
+              <a:t>Compliance check</a:t>
+            </a:r>
+          </a:p>
+        </p:txBody>
+      </p:sp>
+      <p:sp>
+        <p:nvSpPr>
+          <p:cNvPr id="74" name="Rounded Rectangle 73"/>
+          <p:cNvSpPr/>
+          <p:nvPr/>
+        </p:nvSpPr>
+        <p:spPr>
+          <a:xfrm>
+            <a:off x="10945367" y="6784848"/>
+            <a:ext cx="2642616" cy="438912"/>
+          </a:xfrm>
+          <a:prstGeom prst="roundRect">
+            <a:avLst>
+              <a:gd name="adj" fmla="val 50000"/>
+            </a:avLst>
+          </a:prstGeom>
+          <a:solidFill>
+            <a:srgbClr val="F1EAFC"/>
+          </a:solidFill>
+          <a:ln>
+            <a:noFill/>
+          </a:ln>
+          <a:effectLst/>
+        </p:spPr>
+        <p:style>
+          <a:lnRef idx="1">
+            <a:schemeClr val="accent1"/>
+          </a:lnRef>
+          <a:fillRef idx="3">
+            <a:schemeClr val="accent1"/>
+          </a:fillRef>
+          <a:effectRef idx="2">
+            <a:schemeClr val="accent1"/>
+          </a:effectRef>
+          <a:fontRef idx="minor">
+            <a:schemeClr val="lt1"/>
+          </a:fontRef>
+        </p:style>
+        <p:txBody>
+          <a:bodyPr rtlCol="0" anchor="ctr"/>
+          <a:lstStyle/>
+          <a:p>
+            <a:pPr algn="ctr"/>
+          </a:p>
+        </p:txBody>
+      </p:sp>
+      <p:sp>
+        <p:nvSpPr>
+          <p:cNvPr id="75" name="TextBox 74"/>
+          <p:cNvSpPr txBox="1"/>
+          <p:nvPr/>
+        </p:nvSpPr>
+        <p:spPr>
+          <a:xfrm>
+            <a:off x="10945367" y="6784848"/>
+            <a:ext cx="2642616" cy="438912"/>
+          </a:xfrm>
+          <a:prstGeom prst="rect">
+            <a:avLst/>
+          </a:prstGeom>
+          <a:noFill/>
+        </p:spPr>
+        <p:txBody>
+          <a:bodyPr wrap="square" lIns="0" rIns="0" tIns="0" bIns="0" anchor="ctr">
+            <a:noAutofit/>
+          </a:bodyPr>
+          <a:lstStyle/>
+          <a:p>
+            <a:pPr algn="ctr">
+              <a:lnSpc>
+                <a:spcPct val="100000"/>
+              </a:lnSpc>
+              <a:spcBef>
+                <a:spcPts val="0"/>
+              </a:spcBef>
+              <a:spcAft>
+                <a:spcPts val="0"/>
+              </a:spcAft>
+            </a:pPr>
+            <a:r>
+              <a:rPr sz="1350" b="0" i="0">
+                <a:solidFill>
+                  <a:srgbClr val="6D28D9"/>
+                </a:solidFill>
+                <a:latin typeface="Montserrat SemiBold"/>
+              </a:rPr>
+              <a:t>Rank &amp; recommend</a:t>
+            </a:r>
+          </a:p>
+        </p:txBody>
+      </p:sp>
+      <p:sp>
+        <p:nvSpPr>
+          <p:cNvPr id="76" name="Rounded Rectangle 75"/>
+          <p:cNvSpPr/>
+          <p:nvPr/>
+        </p:nvSpPr>
+        <p:spPr>
+          <a:xfrm>
+            <a:off x="10945367" y="7516368"/>
+            <a:ext cx="2642616" cy="420624"/>
+          </a:xfrm>
+          <a:prstGeom prst="roundRect">
+            <a:avLst>
+              <a:gd name="adj" fmla="val 50000"/>
             </a:avLst>
           </a:prstGeom>
           <a:solidFill>
@@ -10576,14 +11020,14 @@
       </p:sp>
       <p:sp>
         <p:nvSpPr>
-          <p:cNvPr id="69" name="TextBox 68"/>
-          <p:cNvSpPr txBox="1"/>
-          <p:nvPr/>
-        </p:nvSpPr>
-        <p:spPr>
-          <a:xfrm>
-            <a:off x="10908792" y="8531352"/>
-            <a:ext cx="2715768" cy="329184"/>
+          <p:cNvPr id="77" name="TextBox 76"/>
+          <p:cNvSpPr txBox="1"/>
+          <p:nvPr/>
+        </p:nvSpPr>
+        <p:spPr>
+          <a:xfrm>
+            <a:off x="10945367" y="7516368"/>
+            <a:ext cx="2642616" cy="420624"/>
           </a:xfrm>
           <a:prstGeom prst="rect">
             <a:avLst/>
@@ -10608,7 +11052,7 @@
               </a:spcAft>
             </a:pPr>
             <a:r>
-              <a:rPr sz="1100" b="1" i="0" spc="80">
+              <a:rPr sz="1100" b="0" i="0" spc="80">
                 <a:solidFill>
                   <a:srgbClr val="146B3F"/>
                 </a:solidFill>
@@ -10621,14 +11065,14 @@
       </p:sp>
       <p:sp>
         <p:nvSpPr>
-          <p:cNvPr id="70" name="Rounded Rectangle 69"/>
+          <p:cNvPr id="78" name="Rounded Rectangle 77"/>
           <p:cNvSpPr/>
           <p:nvPr/>
         </p:nvSpPr>
         <p:spPr>
           <a:xfrm>
-            <a:off x="13999464" y="3246120"/>
-            <a:ext cx="3154680" cy="5806440"/>
+            <a:off x="13999464" y="3291840"/>
+            <a:ext cx="3154680" cy="4892040"/>
           </a:xfrm>
           <a:prstGeom prst="roundRect">
             <a:avLst>
@@ -10669,13 +11113,13 @@
       </p:sp>
       <p:sp>
         <p:nvSpPr>
-          <p:cNvPr id="71" name="Rectangle 70"/>
+          <p:cNvPr id="79" name="Rectangle 78"/>
           <p:cNvSpPr/>
           <p:nvPr/>
         </p:nvSpPr>
         <p:spPr>
           <a:xfrm>
-            <a:off x="13999464" y="3246120"/>
+            <a:off x="13999464" y="3291840"/>
             <a:ext cx="3154680" cy="64008"/>
           </a:xfrm>
           <a:prstGeom prst="rect">
@@ -10713,18 +11157,18 @@
       </p:sp>
       <p:sp>
         <p:nvSpPr>
-          <p:cNvPr id="72" name="Rounded Rectangle 71"/>
+          <p:cNvPr id="80" name="Rounded Rectangle 79"/>
           <p:cNvSpPr/>
           <p:nvPr/>
         </p:nvSpPr>
         <p:spPr>
           <a:xfrm>
-            <a:off x="14218920" y="3538727"/>
-            <a:ext cx="603504" cy="603504"/>
+            <a:off x="14255496" y="3602736"/>
+            <a:ext cx="658368" cy="658368"/>
           </a:xfrm>
           <a:prstGeom prst="roundRect">
             <a:avLst>
-              <a:gd name="adj" fmla="val 18181"/>
+              <a:gd name="adj" fmla="val 19444"/>
             </a:avLst>
           </a:prstGeom>
           <a:solidFill>
@@ -10759,7 +11203,7 @@
       </p:sp>
       <p:pic>
         <p:nvPicPr>
-          <p:cNvPr id="73" name="Picture 72" descr="icon_award_purple.png"/>
+          <p:cNvPr id="81" name="Picture 80" descr="icon_award_purple.png"/>
           <p:cNvPicPr>
             <a:picLocks noChangeAspect="1"/>
           </p:cNvPicPr>
@@ -10773,7 +11217,7 @@
         </p:blipFill>
         <p:spPr>
           <a:xfrm>
-            <a:off x="14337792" y="3657600"/>
+            <a:off x="14401800" y="3749039"/>
             <a:ext cx="365760" cy="365760"/>
           </a:xfrm>
           <a:prstGeom prst="rect">
@@ -10783,14 +11227,14 @@
       </p:pic>
       <p:sp>
         <p:nvSpPr>
-          <p:cNvPr id="74" name="TextBox 73"/>
-          <p:cNvSpPr txBox="1"/>
-          <p:nvPr/>
-        </p:nvSpPr>
-        <p:spPr>
-          <a:xfrm>
-            <a:off x="14932152" y="3557015"/>
-            <a:ext cx="2020824" cy="566928"/>
+          <p:cNvPr id="82" name="TextBox 81"/>
+          <p:cNvSpPr txBox="1"/>
+          <p:nvPr/>
+        </p:nvSpPr>
+        <p:spPr>
+          <a:xfrm>
+            <a:off x="15078455" y="3602736"/>
+            <a:ext cx="1819656" cy="658368"/>
           </a:xfrm>
           <a:prstGeom prst="rect">
             <a:avLst/>
@@ -10828,14 +11272,14 @@
       </p:sp>
       <p:sp>
         <p:nvSpPr>
-          <p:cNvPr id="75" name="TextBox 74"/>
-          <p:cNvSpPr txBox="1"/>
-          <p:nvPr/>
-        </p:nvSpPr>
-        <p:spPr>
-          <a:xfrm>
-            <a:off x="14218920" y="4297679"/>
-            <a:ext cx="2715768" cy="457200"/>
+          <p:cNvPr id="83" name="TextBox 82"/>
+          <p:cNvSpPr txBox="1"/>
+          <p:nvPr/>
+        </p:nvSpPr>
+        <p:spPr>
+          <a:xfrm>
+            <a:off x="14255496" y="4480560"/>
+            <a:ext cx="2642616" cy="502920"/>
           </a:xfrm>
           <a:prstGeom prst="rect">
             <a:avLst/>
@@ -10860,27 +11304,27 @@
               </a:spcAft>
             </a:pPr>
             <a:r>
-              <a:rPr sz="2000" b="0" i="0">
+              <a:rPr sz="2500" b="0" i="0">
                 <a:solidFill>
                   <a:srgbClr val="1B1F26"/>
                 </a:solidFill>
                 <a:latin typeface="Montserrat Medium"/>
               </a:rPr>
-              <a:t>Award Agent</a:t>
-            </a:r>
-          </a:p>
-        </p:txBody>
-      </p:sp>
-      <p:sp>
-        <p:nvSpPr>
-          <p:cNvPr id="76" name="TextBox 75"/>
-          <p:cNvSpPr txBox="1"/>
-          <p:nvPr/>
-        </p:nvSpPr>
-        <p:spPr>
-          <a:xfrm>
-            <a:off x="14218920" y="4818888"/>
-            <a:ext cx="2715768" cy="1097280"/>
+              <a:t>Award</a:t>
+            </a:r>
+          </a:p>
+        </p:txBody>
+      </p:sp>
+      <p:sp>
+        <p:nvSpPr>
+          <p:cNvPr id="84" name="TextBox 83"/>
+          <p:cNvSpPr txBox="1"/>
+          <p:nvPr/>
+        </p:nvSpPr>
+        <p:spPr>
+          <a:xfrm>
+            <a:off x="14255496" y="5120640"/>
+            <a:ext cx="2642616" cy="365760"/>
           </a:xfrm>
           <a:prstGeom prst="rect">
             <a:avLst/>
@@ -10895,86 +11339,96 @@
           <a:p>
             <a:pPr algn="l">
               <a:lnSpc>
-                <a:spcPct val="120000"/>
-              </a:lnSpc>
-              <a:spcBef>
-                <a:spcPts val="0"/>
-              </a:spcBef>
-              <a:spcAft>
-                <a:spcPts val="0"/>
-              </a:spcAft>
-            </a:pPr>
-            <a:r>
-              <a:rPr sz="1300" b="0" i="0">
-                <a:solidFill>
-                  <a:srgbClr val="6A707B"/>
-                </a:solidFill>
-                <a:latin typeface="Montserrat"/>
-              </a:rPr>
-              <a:t>Generates award scenarios and recommends the optimal allocation.</a:t>
-            </a:r>
-          </a:p>
-        </p:txBody>
-      </p:sp>
-      <p:cxnSp>
-        <p:nvCxnSpPr>
-          <p:cNvPr id="77" name="Connector 76"/>
-          <p:cNvCxnSpPr/>
-          <p:nvPr/>
-        </p:nvCxnSpPr>
-        <p:spPr>
-          <a:xfrm>
-            <a:off x="14218920" y="6035040"/>
-            <a:ext cx="2715768" cy="0"/>
-          </a:xfrm>
-          <a:prstGeom prst="bentConnector3">
-            <a:avLst/>
-          </a:prstGeom>
-          <a:ln w="9525">
-            <a:solidFill>
-              <a:srgbClr val="E2E4EA"/>
-            </a:solidFill>
+                <a:spcPct val="100000"/>
+              </a:lnSpc>
+              <a:spcBef>
+                <a:spcPts val="0"/>
+              </a:spcBef>
+              <a:spcAft>
+                <a:spcPts val="0"/>
+              </a:spcAft>
+            </a:pPr>
+            <a:r>
+              <a:rPr sz="1400" b="0" i="0">
+                <a:solidFill>
+                  <a:srgbClr val="7C3AED"/>
+                </a:solidFill>
+                <a:latin typeface="Montserrat Medium"/>
+              </a:rPr>
+              <a:t>Scenario + Writeback</a:t>
+            </a:r>
+          </a:p>
+        </p:txBody>
+      </p:sp>
+      <p:sp>
+        <p:nvSpPr>
+          <p:cNvPr id="85" name="Rounded Rectangle 84"/>
+          <p:cNvSpPr/>
+          <p:nvPr/>
+        </p:nvSpPr>
+        <p:spPr>
+          <a:xfrm>
+            <a:off x="14255496" y="5687568"/>
+            <a:ext cx="2642616" cy="438912"/>
+          </a:xfrm>
+          <a:prstGeom prst="roundRect">
+            <a:avLst>
+              <a:gd name="adj" fmla="val 50000"/>
+            </a:avLst>
+          </a:prstGeom>
+          <a:solidFill>
+            <a:srgbClr val="F1EAFC"/>
+          </a:solidFill>
+          <a:ln>
+            <a:noFill/>
           </a:ln>
           <a:effectLst/>
         </p:spPr>
         <p:style>
-          <a:lnRef idx="2">
+          <a:lnRef idx="1">
             <a:schemeClr val="accent1"/>
           </a:lnRef>
-          <a:fillRef idx="0">
+          <a:fillRef idx="3">
             <a:schemeClr val="accent1"/>
           </a:fillRef>
-          <a:effectRef idx="1">
+          <a:effectRef idx="2">
             <a:schemeClr val="accent1"/>
           </a:effectRef>
           <a:fontRef idx="minor">
-            <a:schemeClr val="tx1"/>
+            <a:schemeClr val="lt1"/>
           </a:fontRef>
         </p:style>
-      </p:cxnSp>
-      <p:sp>
-        <p:nvSpPr>
-          <p:cNvPr id="78" name="TextBox 77"/>
-          <p:cNvSpPr txBox="1"/>
-          <p:nvPr/>
-        </p:nvSpPr>
-        <p:spPr>
-          <a:xfrm>
-            <a:off x="14218920" y="6190488"/>
-            <a:ext cx="2715768" cy="182880"/>
-          </a:xfrm>
-          <a:prstGeom prst="rect">
-            <a:avLst/>
-          </a:prstGeom>
-          <a:noFill/>
-        </p:spPr>
-        <p:txBody>
-          <a:bodyPr wrap="square" lIns="0" rIns="0" tIns="0" bIns="0" anchor="t">
-            <a:noAutofit/>
-          </a:bodyPr>
-          <a:lstStyle/>
-          <a:p>
-            <a:pPr algn="l">
+        <p:txBody>
+          <a:bodyPr rtlCol="0" anchor="ctr"/>
+          <a:lstStyle/>
+          <a:p>
+            <a:pPr algn="ctr"/>
+          </a:p>
+        </p:txBody>
+      </p:sp>
+      <p:sp>
+        <p:nvSpPr>
+          <p:cNvPr id="86" name="TextBox 85"/>
+          <p:cNvSpPr txBox="1"/>
+          <p:nvPr/>
+        </p:nvSpPr>
+        <p:spPr>
+          <a:xfrm>
+            <a:off x="14255496" y="5687568"/>
+            <a:ext cx="2642616" cy="438912"/>
+          </a:xfrm>
+          <a:prstGeom prst="rect">
+            <a:avLst/>
+          </a:prstGeom>
+          <a:noFill/>
+        </p:spPr>
+        <p:txBody>
+          <a:bodyPr wrap="square" lIns="0" rIns="0" tIns="0" bIns="0" anchor="ctr">
+            <a:noAutofit/>
+          </a:bodyPr>
+          <a:lstStyle/>
+          <a:p>
+            <a:pPr algn="ctr">
               <a:lnSpc>
                 <a:spcPct val="100000"/>
               </a:lnSpc>
@@ -10986,121 +11440,213 @@
               </a:spcAft>
             </a:pPr>
             <a:r>
-              <a:rPr sz="950" b="1" i="0" spc="60">
-                <a:solidFill>
-                  <a:srgbClr val="6A707B"/>
-                </a:solidFill>
-                <a:latin typeface="Consolas"/>
-              </a:rPr>
-              <a:t>↓ AERCHAIN CAPABILITY</a:t>
-            </a:r>
-          </a:p>
-        </p:txBody>
-      </p:sp>
-      <p:sp>
-        <p:nvSpPr>
-          <p:cNvPr id="79" name="TextBox 78"/>
-          <p:cNvSpPr txBox="1"/>
-          <p:nvPr/>
-        </p:nvSpPr>
-        <p:spPr>
-          <a:xfrm>
-            <a:off x="14218920" y="6446520"/>
-            <a:ext cx="2715768" cy="548640"/>
-          </a:xfrm>
-          <a:prstGeom prst="rect">
-            <a:avLst/>
-          </a:prstGeom>
-          <a:noFill/>
-        </p:spPr>
-        <p:txBody>
-          <a:bodyPr wrap="square" lIns="0" rIns="0" tIns="0" bIns="0" anchor="t">
-            <a:noAutofit/>
-          </a:bodyPr>
-          <a:lstStyle/>
-          <a:p>
-            <a:pPr algn="l">
-              <a:lnSpc>
-                <a:spcPct val="105000"/>
-              </a:lnSpc>
-              <a:spcBef>
-                <a:spcPts val="0"/>
-              </a:spcBef>
-              <a:spcAft>
-                <a:spcPts val="0"/>
-              </a:spcAft>
-            </a:pPr>
-            <a:r>
-              <a:rPr sz="1500" b="0" i="0">
-                <a:solidFill>
-                  <a:srgbClr val="7C3AED"/>
-                </a:solidFill>
-                <a:latin typeface="Montserrat Medium"/>
-              </a:rPr>
-              <a:t>Scenario + Writeback</a:t>
-            </a:r>
-          </a:p>
-        </p:txBody>
-      </p:sp>
-      <p:sp>
-        <p:nvSpPr>
-          <p:cNvPr id="80" name="TextBox 79"/>
-          <p:cNvSpPr txBox="1"/>
-          <p:nvPr/>
-        </p:nvSpPr>
-        <p:spPr>
-          <a:xfrm>
-            <a:off x="14218920" y="7104888"/>
-            <a:ext cx="2715768" cy="1371600"/>
-          </a:xfrm>
-          <a:prstGeom prst="rect">
-            <a:avLst/>
-          </a:prstGeom>
-          <a:noFill/>
-        </p:spPr>
-        <p:txBody>
-          <a:bodyPr wrap="square" lIns="0" rIns="0" tIns="0" bIns="0" anchor="t">
-            <a:noAutofit/>
-          </a:bodyPr>
-          <a:lstStyle/>
-          <a:p>
-            <a:pPr algn="l">
-              <a:lnSpc>
-                <a:spcPct val="122000"/>
-              </a:lnSpc>
-              <a:spcBef>
-                <a:spcPts val="0"/>
-              </a:spcBef>
-              <a:spcAft>
-                <a:spcPts val="0"/>
-              </a:spcAft>
-            </a:pPr>
-            <a:r>
-              <a:rPr sz="1200" b="0" i="0">
-                <a:solidFill>
-                  <a:srgbClr val="484E59"/>
-                </a:solidFill>
-                <a:latin typeface="Montserrat"/>
-              </a:rPr>
-              <a:t>Constraint-aware allocation factors landed cost, capacity and terms; the approved award writes back to the ERP of record.</a:t>
-            </a:r>
-          </a:p>
-        </p:txBody>
-      </p:sp>
-      <p:sp>
-        <p:nvSpPr>
-          <p:cNvPr id="81" name="Rounded Rectangle 80"/>
+              <a:rPr sz="1350" b="0" i="0">
+                <a:solidFill>
+                  <a:srgbClr val="6D28D9"/>
+                </a:solidFill>
+                <a:latin typeface="Montserrat SemiBold"/>
+              </a:rPr>
+              <a:t>Build scenarios</a:t>
+            </a:r>
+          </a:p>
+        </p:txBody>
+      </p:sp>
+      <p:sp>
+        <p:nvSpPr>
+          <p:cNvPr id="87" name="Rounded Rectangle 86"/>
           <p:cNvSpPr/>
           <p:nvPr/>
         </p:nvSpPr>
         <p:spPr>
           <a:xfrm>
-            <a:off x="14218920" y="8531352"/>
-            <a:ext cx="2715768" cy="329184"/>
+            <a:off x="14255496" y="6236208"/>
+            <a:ext cx="2642616" cy="438912"/>
           </a:xfrm>
           <a:prstGeom prst="roundRect">
             <a:avLst>
-              <a:gd name="adj" fmla="val 13888"/>
+              <a:gd name="adj" fmla="val 50000"/>
+            </a:avLst>
+          </a:prstGeom>
+          <a:solidFill>
+            <a:srgbClr val="F1EAFC"/>
+          </a:solidFill>
+          <a:ln>
+            <a:noFill/>
+          </a:ln>
+          <a:effectLst/>
+        </p:spPr>
+        <p:style>
+          <a:lnRef idx="1">
+            <a:schemeClr val="accent1"/>
+          </a:lnRef>
+          <a:fillRef idx="3">
+            <a:schemeClr val="accent1"/>
+          </a:fillRef>
+          <a:effectRef idx="2">
+            <a:schemeClr val="accent1"/>
+          </a:effectRef>
+          <a:fontRef idx="minor">
+            <a:schemeClr val="lt1"/>
+          </a:fontRef>
+        </p:style>
+        <p:txBody>
+          <a:bodyPr rtlCol="0" anchor="ctr"/>
+          <a:lstStyle/>
+          <a:p>
+            <a:pPr algn="ctr"/>
+          </a:p>
+        </p:txBody>
+      </p:sp>
+      <p:sp>
+        <p:nvSpPr>
+          <p:cNvPr id="88" name="TextBox 87"/>
+          <p:cNvSpPr txBox="1"/>
+          <p:nvPr/>
+        </p:nvSpPr>
+        <p:spPr>
+          <a:xfrm>
+            <a:off x="14255496" y="6236208"/>
+            <a:ext cx="2642616" cy="438912"/>
+          </a:xfrm>
+          <a:prstGeom prst="rect">
+            <a:avLst/>
+          </a:prstGeom>
+          <a:noFill/>
+        </p:spPr>
+        <p:txBody>
+          <a:bodyPr wrap="square" lIns="0" rIns="0" tIns="0" bIns="0" anchor="ctr">
+            <a:noAutofit/>
+          </a:bodyPr>
+          <a:lstStyle/>
+          <a:p>
+            <a:pPr algn="ctr">
+              <a:lnSpc>
+                <a:spcPct val="100000"/>
+              </a:lnSpc>
+              <a:spcBef>
+                <a:spcPts val="0"/>
+              </a:spcBef>
+              <a:spcAft>
+                <a:spcPts val="0"/>
+              </a:spcAft>
+            </a:pPr>
+            <a:r>
+              <a:rPr sz="1350" b="0" i="0">
+                <a:solidFill>
+                  <a:srgbClr val="6D28D9"/>
+                </a:solidFill>
+                <a:latin typeface="Montserrat SemiBold"/>
+              </a:rPr>
+              <a:t>Optimal allocation</a:t>
+            </a:r>
+          </a:p>
+        </p:txBody>
+      </p:sp>
+      <p:sp>
+        <p:nvSpPr>
+          <p:cNvPr id="89" name="Rounded Rectangle 88"/>
+          <p:cNvSpPr/>
+          <p:nvPr/>
+        </p:nvSpPr>
+        <p:spPr>
+          <a:xfrm>
+            <a:off x="14255496" y="6784848"/>
+            <a:ext cx="2642616" cy="438912"/>
+          </a:xfrm>
+          <a:prstGeom prst="roundRect">
+            <a:avLst>
+              <a:gd name="adj" fmla="val 50000"/>
+            </a:avLst>
+          </a:prstGeom>
+          <a:solidFill>
+            <a:srgbClr val="F1EAFC"/>
+          </a:solidFill>
+          <a:ln>
+            <a:noFill/>
+          </a:ln>
+          <a:effectLst/>
+        </p:spPr>
+        <p:style>
+          <a:lnRef idx="1">
+            <a:schemeClr val="accent1"/>
+          </a:lnRef>
+          <a:fillRef idx="3">
+            <a:schemeClr val="accent1"/>
+          </a:fillRef>
+          <a:effectRef idx="2">
+            <a:schemeClr val="accent1"/>
+          </a:effectRef>
+          <a:fontRef idx="minor">
+            <a:schemeClr val="lt1"/>
+          </a:fontRef>
+        </p:style>
+        <p:txBody>
+          <a:bodyPr rtlCol="0" anchor="ctr"/>
+          <a:lstStyle/>
+          <a:p>
+            <a:pPr algn="ctr"/>
+          </a:p>
+        </p:txBody>
+      </p:sp>
+      <p:sp>
+        <p:nvSpPr>
+          <p:cNvPr id="90" name="TextBox 89"/>
+          <p:cNvSpPr txBox="1"/>
+          <p:nvPr/>
+        </p:nvSpPr>
+        <p:spPr>
+          <a:xfrm>
+            <a:off x="14255496" y="6784848"/>
+            <a:ext cx="2642616" cy="438912"/>
+          </a:xfrm>
+          <a:prstGeom prst="rect">
+            <a:avLst/>
+          </a:prstGeom>
+          <a:noFill/>
+        </p:spPr>
+        <p:txBody>
+          <a:bodyPr wrap="square" lIns="0" rIns="0" tIns="0" bIns="0" anchor="ctr">
+            <a:noAutofit/>
+          </a:bodyPr>
+          <a:lstStyle/>
+          <a:p>
+            <a:pPr algn="ctr">
+              <a:lnSpc>
+                <a:spcPct val="100000"/>
+              </a:lnSpc>
+              <a:spcBef>
+                <a:spcPts val="0"/>
+              </a:spcBef>
+              <a:spcAft>
+                <a:spcPts val="0"/>
+              </a:spcAft>
+            </a:pPr>
+            <a:r>
+              <a:rPr sz="1350" b="0" i="0">
+                <a:solidFill>
+                  <a:srgbClr val="6D28D9"/>
+                </a:solidFill>
+                <a:latin typeface="Montserrat SemiBold"/>
+              </a:rPr>
+              <a:t>Write back to ERP</a:t>
+            </a:r>
+          </a:p>
+        </p:txBody>
+      </p:sp>
+      <p:sp>
+        <p:nvSpPr>
+          <p:cNvPr id="91" name="Rounded Rectangle 90"/>
+          <p:cNvSpPr/>
+          <p:nvPr/>
+        </p:nvSpPr>
+        <p:spPr>
+          <a:xfrm>
+            <a:off x="14255496" y="7516368"/>
+            <a:ext cx="2642616" cy="420624"/>
+          </a:xfrm>
+          <a:prstGeom prst="roundRect">
+            <a:avLst>
+              <a:gd name="adj" fmla="val 50000"/>
             </a:avLst>
           </a:prstGeom>
           <a:solidFill>
@@ -11137,14 +11683,14 @@
       </p:sp>
       <p:sp>
         <p:nvSpPr>
-          <p:cNvPr id="82" name="TextBox 81"/>
-          <p:cNvSpPr txBox="1"/>
-          <p:nvPr/>
-        </p:nvSpPr>
-        <p:spPr>
-          <a:xfrm>
-            <a:off x="14218920" y="8531352"/>
-            <a:ext cx="2715768" cy="329184"/>
+          <p:cNvPr id="92" name="TextBox 91"/>
+          <p:cNvSpPr txBox="1"/>
+          <p:nvPr/>
+        </p:nvSpPr>
+        <p:spPr>
+          <a:xfrm>
+            <a:off x="14255496" y="7516368"/>
+            <a:ext cx="2642616" cy="420624"/>
           </a:xfrm>
           <a:prstGeom prst="rect">
             <a:avLst/>
@@ -11169,7 +11715,7 @@
               </a:spcAft>
             </a:pPr>
             <a:r>
-              <a:rPr sz="1100" b="1" i="0" spc="80">
+              <a:rPr sz="1100" b="0" i="0" spc="80">
                 <a:solidFill>
                   <a:srgbClr val="146B3F"/>
                 </a:solidFill>
@@ -11182,61 +11728,680 @@
       </p:sp>
       <p:sp>
         <p:nvSpPr>
-          <p:cNvPr id="83" name="TextBox 82"/>
-          <p:cNvSpPr txBox="1"/>
-          <p:nvPr/>
-        </p:nvSpPr>
-        <p:spPr>
-          <a:xfrm>
-            <a:off x="758952" y="9281160"/>
-            <a:ext cx="16770096" cy="457200"/>
-          </a:xfrm>
-          <a:prstGeom prst="rect">
-            <a:avLst/>
-          </a:prstGeom>
-          <a:noFill/>
-        </p:spPr>
-        <p:txBody>
-          <a:bodyPr wrap="square" lIns="0" rIns="0" tIns="0" bIns="0" anchor="t">
+          <p:cNvPr id="93" name="Rounded Rectangle 92"/>
+          <p:cNvSpPr/>
+          <p:nvPr/>
+        </p:nvSpPr>
+        <p:spPr>
+          <a:xfrm>
+            <a:off x="758952" y="8503920"/>
+            <a:ext cx="16770096" cy="960120"/>
+          </a:xfrm>
+          <a:prstGeom prst="roundRect">
+            <a:avLst>
+              <a:gd name="adj" fmla="val 9523"/>
+            </a:avLst>
+          </a:prstGeom>
+          <a:solidFill>
+            <a:srgbClr val="FFFFFF"/>
+          </a:solidFill>
+          <a:ln w="9525">
+            <a:solidFill>
+              <a:srgbClr val="E2E4EA"/>
+            </a:solidFill>
+          </a:ln>
+          <a:effectLst/>
+        </p:spPr>
+        <p:style>
+          <a:lnRef idx="1">
+            <a:schemeClr val="accent1"/>
+          </a:lnRef>
+          <a:fillRef idx="3">
+            <a:schemeClr val="accent1"/>
+          </a:fillRef>
+          <a:effectRef idx="2">
+            <a:schemeClr val="accent1"/>
+          </a:effectRef>
+          <a:fontRef idx="minor">
+            <a:schemeClr val="lt1"/>
+          </a:fontRef>
+        </p:style>
+        <p:txBody>
+          <a:bodyPr rtlCol="0" anchor="ctr"/>
+          <a:lstStyle/>
+          <a:p>
+            <a:pPr algn="ctr"/>
+          </a:p>
+        </p:txBody>
+      </p:sp>
+      <p:sp>
+        <p:nvSpPr>
+          <p:cNvPr id="94" name="TextBox 93"/>
+          <p:cNvSpPr txBox="1"/>
+          <p:nvPr/>
+        </p:nvSpPr>
+        <p:spPr>
+          <a:xfrm>
+            <a:off x="1051560" y="8503920"/>
+            <a:ext cx="2834640" cy="960120"/>
+          </a:xfrm>
+          <a:prstGeom prst="rect">
+            <a:avLst/>
+          </a:prstGeom>
+          <a:noFill/>
+        </p:spPr>
+        <p:txBody>
+          <a:bodyPr wrap="square" lIns="0" rIns="0" tIns="0" bIns="0" anchor="ctr">
             <a:noAutofit/>
           </a:bodyPr>
           <a:lstStyle/>
           <a:p>
             <a:pPr algn="l">
               <a:lnSpc>
-                <a:spcPct val="120000"/>
-              </a:lnSpc>
-              <a:spcBef>
-                <a:spcPts val="0"/>
-              </a:spcBef>
-              <a:spcAft>
-                <a:spcPts val="0"/>
-              </a:spcAft>
-            </a:pPr>
-            <a:r>
-              <a:rPr sz="1450" b="0" i="0">
+                <a:spcPct val="125000"/>
+              </a:lnSpc>
+              <a:spcBef>
+                <a:spcPts val="0"/>
+              </a:spcBef>
+              <a:spcAft>
+                <a:spcPts val="300"/>
+              </a:spcAft>
+            </a:pPr>
+            <a:r>
+              <a:rPr sz="1300" b="1" i="0" spc="120">
+                <a:solidFill>
+                  <a:srgbClr val="7C3AED"/>
+                </a:solidFill>
+                <a:latin typeface="Consolas"/>
+              </a:rPr>
+              <a:t>GUARDRAILS</a:t>
+            </a:r>
+          </a:p>
+          <a:p>
+            <a:pPr algn="l">
+              <a:lnSpc>
+                <a:spcPct val="125000"/>
+              </a:lnSpc>
+              <a:spcBef>
+                <a:spcPts val="0"/>
+              </a:spcBef>
+              <a:spcAft>
+                <a:spcPts val="300"/>
+              </a:spcAft>
+            </a:pPr>
+            <a:r>
+              <a:rPr sz="1150" b="0" i="0">
+                <a:solidFill>
+                  <a:srgbClr val="6A707B"/>
+                </a:solidFill>
+                <a:latin typeface="Montserrat"/>
+              </a:rPr>
+              <a:t>Every step · per category</a:t>
+            </a:r>
+          </a:p>
+        </p:txBody>
+      </p:sp>
+      <p:sp>
+        <p:nvSpPr>
+          <p:cNvPr id="95" name="Rounded Rectangle 94"/>
+          <p:cNvSpPr/>
+          <p:nvPr/>
+        </p:nvSpPr>
+        <p:spPr>
+          <a:xfrm>
+            <a:off x="4114800" y="8796528"/>
+            <a:ext cx="2072640" cy="384048"/>
+          </a:xfrm>
+          <a:prstGeom prst="roundRect">
+            <a:avLst>
+              <a:gd name="adj" fmla="val 50000"/>
+            </a:avLst>
+          </a:prstGeom>
+          <a:solidFill>
+            <a:srgbClr val="FAFBFC"/>
+          </a:solidFill>
+          <a:ln w="9525">
+            <a:solidFill>
+              <a:srgbClr val="E2E4EA"/>
+            </a:solidFill>
+          </a:ln>
+          <a:effectLst/>
+        </p:spPr>
+        <p:style>
+          <a:lnRef idx="1">
+            <a:schemeClr val="accent1"/>
+          </a:lnRef>
+          <a:fillRef idx="3">
+            <a:schemeClr val="accent1"/>
+          </a:fillRef>
+          <a:effectRef idx="2">
+            <a:schemeClr val="accent1"/>
+          </a:effectRef>
+          <a:fontRef idx="minor">
+            <a:schemeClr val="lt1"/>
+          </a:fontRef>
+        </p:style>
+        <p:txBody>
+          <a:bodyPr rtlCol="0" anchor="ctr"/>
+          <a:lstStyle/>
+          <a:p>
+            <a:pPr algn="ctr"/>
+          </a:p>
+        </p:txBody>
+      </p:sp>
+      <p:sp>
+        <p:nvSpPr>
+          <p:cNvPr id="96" name="TextBox 95"/>
+          <p:cNvSpPr txBox="1"/>
+          <p:nvPr/>
+        </p:nvSpPr>
+        <p:spPr>
+          <a:xfrm>
+            <a:off x="4114800" y="8796528"/>
+            <a:ext cx="2072640" cy="384048"/>
+          </a:xfrm>
+          <a:prstGeom prst="rect">
+            <a:avLst/>
+          </a:prstGeom>
+          <a:noFill/>
+        </p:spPr>
+        <p:txBody>
+          <a:bodyPr wrap="square" lIns="0" rIns="0" tIns="0" bIns="0" anchor="ctr">
+            <a:noAutofit/>
+          </a:bodyPr>
+          <a:lstStyle/>
+          <a:p>
+            <a:pPr algn="ctr">
+              <a:lnSpc>
+                <a:spcPct val="100000"/>
+              </a:lnSpc>
+              <a:spcBef>
+                <a:spcPts val="0"/>
+              </a:spcBef>
+              <a:spcAft>
+                <a:spcPts val="0"/>
+              </a:spcAft>
+            </a:pPr>
+            <a:r>
+              <a:rPr sz="1150" b="0" i="0">
                 <a:solidFill>
                   <a:srgbClr val="1B1F26"/>
                 </a:solidFill>
                 <a:latin typeface="Montserrat SemiBold"/>
               </a:rPr>
-              <a:t>Delivery posture.  </a:t>
-            </a:r>
-            <a:r>
-              <a:rPr sz="1450" b="0" i="0">
-                <a:solidFill>
-                  <a:srgbClr val="484E59"/>
-                </a:solidFill>
-                <a:latin typeface="Montserrat"/>
-              </a:rPr>
-              <a:t>All five agents are in production today — Intake, Sourcing, Negotiation, Evaluation and Award — orchestrated end-to-end, with the ERP kept as the system of record.</a:t>
-            </a:r>
-          </a:p>
-        </p:txBody>
-      </p:sp>
-      <p:sp>
-        <p:nvSpPr>
-          <p:cNvPr id="84" name="Rectangle 83"/>
+              <a:t>Hard limits</a:t>
+            </a:r>
+          </a:p>
+        </p:txBody>
+      </p:sp>
+      <p:sp>
+        <p:nvSpPr>
+          <p:cNvPr id="97" name="Rounded Rectangle 96"/>
+          <p:cNvSpPr/>
+          <p:nvPr/>
+        </p:nvSpPr>
+        <p:spPr>
+          <a:xfrm>
+            <a:off x="6352032" y="8796528"/>
+            <a:ext cx="2072640" cy="384048"/>
+          </a:xfrm>
+          <a:prstGeom prst="roundRect">
+            <a:avLst>
+              <a:gd name="adj" fmla="val 50000"/>
+            </a:avLst>
+          </a:prstGeom>
+          <a:solidFill>
+            <a:srgbClr val="FAFBFC"/>
+          </a:solidFill>
+          <a:ln w="9525">
+            <a:solidFill>
+              <a:srgbClr val="E2E4EA"/>
+            </a:solidFill>
+          </a:ln>
+          <a:effectLst/>
+        </p:spPr>
+        <p:style>
+          <a:lnRef idx="1">
+            <a:schemeClr val="accent1"/>
+          </a:lnRef>
+          <a:fillRef idx="3">
+            <a:schemeClr val="accent1"/>
+          </a:fillRef>
+          <a:effectRef idx="2">
+            <a:schemeClr val="accent1"/>
+          </a:effectRef>
+          <a:fontRef idx="minor">
+            <a:schemeClr val="lt1"/>
+          </a:fontRef>
+        </p:style>
+        <p:txBody>
+          <a:bodyPr rtlCol="0" anchor="ctr"/>
+          <a:lstStyle/>
+          <a:p>
+            <a:pPr algn="ctr"/>
+          </a:p>
+        </p:txBody>
+      </p:sp>
+      <p:sp>
+        <p:nvSpPr>
+          <p:cNvPr id="98" name="TextBox 97"/>
+          <p:cNvSpPr txBox="1"/>
+          <p:nvPr/>
+        </p:nvSpPr>
+        <p:spPr>
+          <a:xfrm>
+            <a:off x="6352032" y="8796528"/>
+            <a:ext cx="2072640" cy="384048"/>
+          </a:xfrm>
+          <a:prstGeom prst="rect">
+            <a:avLst/>
+          </a:prstGeom>
+          <a:noFill/>
+        </p:spPr>
+        <p:txBody>
+          <a:bodyPr wrap="square" lIns="0" rIns="0" tIns="0" bIns="0" anchor="ctr">
+            <a:noAutofit/>
+          </a:bodyPr>
+          <a:lstStyle/>
+          <a:p>
+            <a:pPr algn="ctr">
+              <a:lnSpc>
+                <a:spcPct val="100000"/>
+              </a:lnSpc>
+              <a:spcBef>
+                <a:spcPts val="0"/>
+              </a:spcBef>
+              <a:spcAft>
+                <a:spcPts val="0"/>
+              </a:spcAft>
+            </a:pPr>
+            <a:r>
+              <a:rPr sz="1150" b="0" i="0">
+                <a:solidFill>
+                  <a:srgbClr val="1B1F26"/>
+                </a:solidFill>
+                <a:latin typeface="Montserrat SemiBold"/>
+              </a:rPr>
+              <a:t>&gt;5% deviation</a:t>
+            </a:r>
+          </a:p>
+        </p:txBody>
+      </p:sp>
+      <p:sp>
+        <p:nvSpPr>
+          <p:cNvPr id="99" name="Rounded Rectangle 98"/>
+          <p:cNvSpPr/>
+          <p:nvPr/>
+        </p:nvSpPr>
+        <p:spPr>
+          <a:xfrm>
+            <a:off x="8589264" y="8796528"/>
+            <a:ext cx="2072640" cy="384048"/>
+          </a:xfrm>
+          <a:prstGeom prst="roundRect">
+            <a:avLst>
+              <a:gd name="adj" fmla="val 50000"/>
+            </a:avLst>
+          </a:prstGeom>
+          <a:solidFill>
+            <a:srgbClr val="FAFBFC"/>
+          </a:solidFill>
+          <a:ln w="9525">
+            <a:solidFill>
+              <a:srgbClr val="E2E4EA"/>
+            </a:solidFill>
+          </a:ln>
+          <a:effectLst/>
+        </p:spPr>
+        <p:style>
+          <a:lnRef idx="1">
+            <a:schemeClr val="accent1"/>
+          </a:lnRef>
+          <a:fillRef idx="3">
+            <a:schemeClr val="accent1"/>
+          </a:fillRef>
+          <a:effectRef idx="2">
+            <a:schemeClr val="accent1"/>
+          </a:effectRef>
+          <a:fontRef idx="minor">
+            <a:schemeClr val="lt1"/>
+          </a:fontRef>
+        </p:style>
+        <p:txBody>
+          <a:bodyPr rtlCol="0" anchor="ctr"/>
+          <a:lstStyle/>
+          <a:p>
+            <a:pPr algn="ctr"/>
+          </a:p>
+        </p:txBody>
+      </p:sp>
+      <p:sp>
+        <p:nvSpPr>
+          <p:cNvPr id="100" name="TextBox 99"/>
+          <p:cNvSpPr txBox="1"/>
+          <p:nvPr/>
+        </p:nvSpPr>
+        <p:spPr>
+          <a:xfrm>
+            <a:off x="8589264" y="8796528"/>
+            <a:ext cx="2072640" cy="384048"/>
+          </a:xfrm>
+          <a:prstGeom prst="rect">
+            <a:avLst/>
+          </a:prstGeom>
+          <a:noFill/>
+        </p:spPr>
+        <p:txBody>
+          <a:bodyPr wrap="square" lIns="0" rIns="0" tIns="0" bIns="0" anchor="ctr">
+            <a:noAutofit/>
+          </a:bodyPr>
+          <a:lstStyle/>
+          <a:p>
+            <a:pPr algn="ctr">
+              <a:lnSpc>
+                <a:spcPct val="100000"/>
+              </a:lnSpc>
+              <a:spcBef>
+                <a:spcPts val="0"/>
+              </a:spcBef>
+              <a:spcAft>
+                <a:spcPts val="0"/>
+              </a:spcAft>
+            </a:pPr>
+            <a:r>
+              <a:rPr sz="1150" b="0" i="0">
+                <a:solidFill>
+                  <a:srgbClr val="1B1F26"/>
+                </a:solidFill>
+                <a:latin typeface="Montserrat SemiBold"/>
+              </a:rPr>
+              <a:t>SoD matrix</a:t>
+            </a:r>
+          </a:p>
+        </p:txBody>
+      </p:sp>
+      <p:sp>
+        <p:nvSpPr>
+          <p:cNvPr id="101" name="Rounded Rectangle 100"/>
+          <p:cNvSpPr/>
+          <p:nvPr/>
+        </p:nvSpPr>
+        <p:spPr>
+          <a:xfrm>
+            <a:off x="10826496" y="8796528"/>
+            <a:ext cx="2072640" cy="384048"/>
+          </a:xfrm>
+          <a:prstGeom prst="roundRect">
+            <a:avLst>
+              <a:gd name="adj" fmla="val 50000"/>
+            </a:avLst>
+          </a:prstGeom>
+          <a:solidFill>
+            <a:srgbClr val="FAFBFC"/>
+          </a:solidFill>
+          <a:ln w="9525">
+            <a:solidFill>
+              <a:srgbClr val="E2E4EA"/>
+            </a:solidFill>
+          </a:ln>
+          <a:effectLst/>
+        </p:spPr>
+        <p:style>
+          <a:lnRef idx="1">
+            <a:schemeClr val="accent1"/>
+          </a:lnRef>
+          <a:fillRef idx="3">
+            <a:schemeClr val="accent1"/>
+          </a:fillRef>
+          <a:effectRef idx="2">
+            <a:schemeClr val="accent1"/>
+          </a:effectRef>
+          <a:fontRef idx="minor">
+            <a:schemeClr val="lt1"/>
+          </a:fontRef>
+        </p:style>
+        <p:txBody>
+          <a:bodyPr rtlCol="0" anchor="ctr"/>
+          <a:lstStyle/>
+          <a:p>
+            <a:pPr algn="ctr"/>
+          </a:p>
+        </p:txBody>
+      </p:sp>
+      <p:sp>
+        <p:nvSpPr>
+          <p:cNvPr id="102" name="TextBox 101"/>
+          <p:cNvSpPr txBox="1"/>
+          <p:nvPr/>
+        </p:nvSpPr>
+        <p:spPr>
+          <a:xfrm>
+            <a:off x="10826496" y="8796528"/>
+            <a:ext cx="2072640" cy="384048"/>
+          </a:xfrm>
+          <a:prstGeom prst="rect">
+            <a:avLst/>
+          </a:prstGeom>
+          <a:noFill/>
+        </p:spPr>
+        <p:txBody>
+          <a:bodyPr wrap="square" lIns="0" rIns="0" tIns="0" bIns="0" anchor="ctr">
+            <a:noAutofit/>
+          </a:bodyPr>
+          <a:lstStyle/>
+          <a:p>
+            <a:pPr algn="ctr">
+              <a:lnSpc>
+                <a:spcPct val="100000"/>
+              </a:lnSpc>
+              <a:spcBef>
+                <a:spcPts val="0"/>
+              </a:spcBef>
+              <a:spcAft>
+                <a:spcPts val="0"/>
+              </a:spcAft>
+            </a:pPr>
+            <a:r>
+              <a:rPr sz="1150" b="0" i="0">
+                <a:solidFill>
+                  <a:srgbClr val="1B1F26"/>
+                </a:solidFill>
+                <a:latin typeface="Montserrat SemiBold"/>
+              </a:rPr>
+              <a:t>Immutable audit log</a:t>
+            </a:r>
+          </a:p>
+        </p:txBody>
+      </p:sp>
+      <p:sp>
+        <p:nvSpPr>
+          <p:cNvPr id="103" name="Rounded Rectangle 102"/>
+          <p:cNvSpPr/>
+          <p:nvPr/>
+        </p:nvSpPr>
+        <p:spPr>
+          <a:xfrm>
+            <a:off x="13063728" y="8796528"/>
+            <a:ext cx="2072640" cy="384048"/>
+          </a:xfrm>
+          <a:prstGeom prst="roundRect">
+            <a:avLst>
+              <a:gd name="adj" fmla="val 50000"/>
+            </a:avLst>
+          </a:prstGeom>
+          <a:solidFill>
+            <a:srgbClr val="FAFBFC"/>
+          </a:solidFill>
+          <a:ln w="9525">
+            <a:solidFill>
+              <a:srgbClr val="E2E4EA"/>
+            </a:solidFill>
+          </a:ln>
+          <a:effectLst/>
+        </p:spPr>
+        <p:style>
+          <a:lnRef idx="1">
+            <a:schemeClr val="accent1"/>
+          </a:lnRef>
+          <a:fillRef idx="3">
+            <a:schemeClr val="accent1"/>
+          </a:fillRef>
+          <a:effectRef idx="2">
+            <a:schemeClr val="accent1"/>
+          </a:effectRef>
+          <a:fontRef idx="minor">
+            <a:schemeClr val="lt1"/>
+          </a:fontRef>
+        </p:style>
+        <p:txBody>
+          <a:bodyPr rtlCol="0" anchor="ctr"/>
+          <a:lstStyle/>
+          <a:p>
+            <a:pPr algn="ctr"/>
+          </a:p>
+        </p:txBody>
+      </p:sp>
+      <p:sp>
+        <p:nvSpPr>
+          <p:cNvPr id="104" name="TextBox 103"/>
+          <p:cNvSpPr txBox="1"/>
+          <p:nvPr/>
+        </p:nvSpPr>
+        <p:spPr>
+          <a:xfrm>
+            <a:off x="13063728" y="8796528"/>
+            <a:ext cx="2072640" cy="384048"/>
+          </a:xfrm>
+          <a:prstGeom prst="rect">
+            <a:avLst/>
+          </a:prstGeom>
+          <a:noFill/>
+        </p:spPr>
+        <p:txBody>
+          <a:bodyPr wrap="square" lIns="0" rIns="0" tIns="0" bIns="0" anchor="ctr">
+            <a:noAutofit/>
+          </a:bodyPr>
+          <a:lstStyle/>
+          <a:p>
+            <a:pPr algn="ctr">
+              <a:lnSpc>
+                <a:spcPct val="100000"/>
+              </a:lnSpc>
+              <a:spcBef>
+                <a:spcPts val="0"/>
+              </a:spcBef>
+              <a:spcAft>
+                <a:spcPts val="0"/>
+              </a:spcAft>
+            </a:pPr>
+            <a:r>
+              <a:rPr sz="1150" b="0" i="0">
+                <a:solidFill>
+                  <a:srgbClr val="1B1F26"/>
+                </a:solidFill>
+                <a:latin typeface="Montserrat SemiBold"/>
+              </a:rPr>
+              <a:t>Auto-blacklist</a:t>
+            </a:r>
+          </a:p>
+        </p:txBody>
+      </p:sp>
+      <p:sp>
+        <p:nvSpPr>
+          <p:cNvPr id="105" name="Rounded Rectangle 104"/>
+          <p:cNvSpPr/>
+          <p:nvPr/>
+        </p:nvSpPr>
+        <p:spPr>
+          <a:xfrm>
+            <a:off x="15300960" y="8796528"/>
+            <a:ext cx="2072640" cy="384048"/>
+          </a:xfrm>
+          <a:prstGeom prst="roundRect">
+            <a:avLst>
+              <a:gd name="adj" fmla="val 50000"/>
+            </a:avLst>
+          </a:prstGeom>
+          <a:solidFill>
+            <a:srgbClr val="FAFBFC"/>
+          </a:solidFill>
+          <a:ln w="9525">
+            <a:solidFill>
+              <a:srgbClr val="E2E4EA"/>
+            </a:solidFill>
+          </a:ln>
+          <a:effectLst/>
+        </p:spPr>
+        <p:style>
+          <a:lnRef idx="1">
+            <a:schemeClr val="accent1"/>
+          </a:lnRef>
+          <a:fillRef idx="3">
+            <a:schemeClr val="accent1"/>
+          </a:fillRef>
+          <a:effectRef idx="2">
+            <a:schemeClr val="accent1"/>
+          </a:effectRef>
+          <a:fontRef idx="minor">
+            <a:schemeClr val="lt1"/>
+          </a:fontRef>
+        </p:style>
+        <p:txBody>
+          <a:bodyPr rtlCol="0" anchor="ctr"/>
+          <a:lstStyle/>
+          <a:p>
+            <a:pPr algn="ctr"/>
+          </a:p>
+        </p:txBody>
+      </p:sp>
+      <p:sp>
+        <p:nvSpPr>
+          <p:cNvPr id="106" name="TextBox 105"/>
+          <p:cNvSpPr txBox="1"/>
+          <p:nvPr/>
+        </p:nvSpPr>
+        <p:spPr>
+          <a:xfrm>
+            <a:off x="15300960" y="8796528"/>
+            <a:ext cx="2072640" cy="384048"/>
+          </a:xfrm>
+          <a:prstGeom prst="rect">
+            <a:avLst/>
+          </a:prstGeom>
+          <a:noFill/>
+        </p:spPr>
+        <p:txBody>
+          <a:bodyPr wrap="square" lIns="0" rIns="0" tIns="0" bIns="0" anchor="ctr">
+            <a:noAutofit/>
+          </a:bodyPr>
+          <a:lstStyle/>
+          <a:p>
+            <a:pPr algn="ctr">
+              <a:lnSpc>
+                <a:spcPct val="100000"/>
+              </a:lnSpc>
+              <a:spcBef>
+                <a:spcPts val="0"/>
+              </a:spcBef>
+              <a:spcAft>
+                <a:spcPts val="0"/>
+              </a:spcAft>
+            </a:pPr>
+            <a:r>
+              <a:rPr sz="1150" b="0" i="0">
+                <a:solidFill>
+                  <a:srgbClr val="1B1F26"/>
+                </a:solidFill>
+                <a:latin typeface="Montserrat SemiBold"/>
+              </a:rPr>
+              <a:t>Human-in-the-loop</a:t>
+            </a:r>
+          </a:p>
+        </p:txBody>
+      </p:sp>
+      <p:sp>
+        <p:nvSpPr>
+          <p:cNvPr id="107" name="Rectangle 106"/>
           <p:cNvSpPr/>
           <p:nvPr/>
         </p:nvSpPr>
@@ -11280,7 +12445,7 @@
       </p:sp>
       <p:cxnSp>
         <p:nvCxnSpPr>
-          <p:cNvPr id="85" name="Connector 84"/>
+          <p:cNvPr id="108" name="Connector 107"/>
           <p:cNvCxnSpPr/>
           <p:nvPr/>
         </p:nvCxnSpPr>
@@ -11316,7 +12481,7 @@
       </p:cxnSp>
       <p:sp>
         <p:nvSpPr>
-          <p:cNvPr id="86" name="TextBox 85"/>
+          <p:cNvPr id="109" name="TextBox 108"/>
           <p:cNvSpPr txBox="1"/>
           <p:nvPr/>
         </p:nvSpPr>
@@ -11361,7 +12526,7 @@
       </p:sp>
       <p:sp>
         <p:nvSpPr>
-          <p:cNvPr id="87" name="TextBox 86"/>
+          <p:cNvPr id="110" name="TextBox 109"/>
           <p:cNvSpPr txBox="1"/>
           <p:nvPr/>
         </p:nvSpPr>
@@ -11562,8 +12727,8 @@
         </p:blipFill>
         <p:spPr>
           <a:xfrm>
-            <a:off x="758952" y="292608"/>
-            <a:ext cx="2542032" cy="365760"/>
+            <a:off x="758952" y="256032"/>
+            <a:ext cx="2660904" cy="384048"/>
           </a:xfrm>
           <a:prstGeom prst="rect">
             <a:avLst/>
@@ -11578,8 +12743,8 @@
         </p:nvSpPr>
         <p:spPr>
           <a:xfrm>
-            <a:off x="3456432" y="0"/>
-            <a:ext cx="457200" cy="960120"/>
+            <a:off x="3474720" y="256032"/>
+            <a:ext cx="502920" cy="384048"/>
           </a:xfrm>
           <a:prstGeom prst="rect">
             <a:avLst/>
@@ -11604,7 +12769,7 @@
               </a:spcAft>
             </a:pPr>
             <a:r>
-              <a:rPr sz="1800" b="0" i="0">
+              <a:rPr sz="2000" b="0" i="0">
                 <a:solidFill>
                   <a:srgbClr val="6A707B"/>
                 </a:solidFill>
@@ -11631,8 +12796,8 @@
         </p:blipFill>
         <p:spPr>
           <a:xfrm>
-            <a:off x="3977639" y="338328"/>
-            <a:ext cx="749808" cy="292608"/>
+            <a:off x="4023360" y="256032"/>
+            <a:ext cx="1188720" cy="466344"/>
           </a:xfrm>
           <a:prstGeom prst="rect">
             <a:avLst/>
@@ -11647,8 +12812,8 @@
         </p:nvCxnSpPr>
         <p:spPr>
           <a:xfrm>
-            <a:off x="5074920" y="338328"/>
-            <a:ext cx="0" cy="283464"/>
+            <a:off x="5468112" y="274320"/>
+            <a:ext cx="0" cy="411480"/>
           </a:xfrm>
           <a:prstGeom prst="bentConnector3">
             <a:avLst/>
@@ -11683,8 +12848,8 @@
         </p:nvSpPr>
         <p:spPr>
           <a:xfrm>
-            <a:off x="5285232" y="0"/>
-            <a:ext cx="8686800" cy="960120"/>
+            <a:off x="5687568" y="0"/>
+            <a:ext cx="8229600" cy="960120"/>
           </a:xfrm>
           <a:prstGeom prst="rect">
             <a:avLst/>
@@ -11728,8 +12893,8 @@
         </p:nvSpPr>
         <p:spPr>
           <a:xfrm>
-            <a:off x="14996159" y="0"/>
-            <a:ext cx="1645920" cy="960120"/>
+            <a:off x="14356080" y="0"/>
+            <a:ext cx="2103120" cy="960120"/>
           </a:xfrm>
           <a:prstGeom prst="rect">
             <a:avLst/>
@@ -11790,8 +12955,8 @@
         </p:blipFill>
         <p:spPr>
           <a:xfrm>
-            <a:off x="16916400" y="256032"/>
-            <a:ext cx="457200" cy="475488"/>
+            <a:off x="16751808" y="155448"/>
+            <a:ext cx="594360" cy="658368"/>
           </a:xfrm>
           <a:prstGeom prst="rect">
             <a:avLst/>
@@ -14031,10 +15196,10 @@
           <a:gradFill rotWithShape="1">
             <a:gsLst>
               <a:gs pos="0">
-                <a:srgbClr val="0F766E"/>
+                <a:srgbClr val="2E1065"/>
               </a:gs>
               <a:gs pos="100000">
-                <a:srgbClr val="13B5A6"/>
+                <a:srgbClr val="4C1D95"/>
               </a:gs>
             </a:gsLst>
             <a:lin scaled="0" ang="18600000"/>
@@ -14102,7 +15267,7 @@
             <a:r>
               <a:rPr sz="1200" b="1" i="0" spc="120">
                 <a:solidFill>
-                  <a:srgbClr val="CCFBF1"/>
+                  <a:srgbClr val="D8C9F5"/>
                 </a:solidFill>
                 <a:latin typeface="Consolas"/>
               </a:rPr>
@@ -14128,7 +15293,7 @@
             </a:avLst>
           </a:prstGeom>
           <a:solidFill>
-            <a:srgbClr val="0B5B55"/>
+            <a:srgbClr val="3B1A6B"/>
           </a:solidFill>
           <a:ln>
             <a:noFill/>
@@ -14193,7 +15358,7 @@
             <a:r>
               <a:rPr sz="1050" b="1" i="0" spc="120">
                 <a:solidFill>
-                  <a:srgbClr val="CCFBF1"/>
+                  <a:srgbClr val="D8C9F5"/>
                 </a:solidFill>
                 <a:latin typeface="Consolas"/>
               </a:rPr>
@@ -14283,7 +15448,7 @@
             <a:r>
               <a:rPr sz="1200" b="0" i="0">
                 <a:solidFill>
-                  <a:srgbClr val="CCFBF1"/>
+                  <a:srgbClr val="D8C9F5"/>
                 </a:solidFill>
                 <a:latin typeface="Montserrat"/>
               </a:rPr>
@@ -14354,7 +15519,7 @@
             </a:avLst>
           </a:prstGeom>
           <a:solidFill>
-            <a:srgbClr val="0B5B55"/>
+            <a:srgbClr val="3B1A6B"/>
           </a:solidFill>
           <a:ln>
             <a:noFill/>
@@ -14419,7 +15584,7 @@
             <a:r>
               <a:rPr sz="1050" b="1" i="0" spc="120">
                 <a:solidFill>
-                  <a:srgbClr val="CCFBF1"/>
+                  <a:srgbClr val="D8C9F5"/>
                 </a:solidFill>
                 <a:latin typeface="Consolas"/>
               </a:rPr>
@@ -14509,7 +15674,7 @@
             <a:r>
               <a:rPr sz="1200" b="0" i="0">
                 <a:solidFill>
-                  <a:srgbClr val="CCFBF1"/>
+                  <a:srgbClr val="D8C9F5"/>
                 </a:solidFill>
                 <a:latin typeface="Montserrat"/>
               </a:rPr>
@@ -14580,7 +15745,7 @@
             </a:avLst>
           </a:prstGeom>
           <a:solidFill>
-            <a:srgbClr val="0B5B55"/>
+            <a:srgbClr val="3B1A6B"/>
           </a:solidFill>
           <a:ln>
             <a:noFill/>
@@ -14645,7 +15810,7 @@
             <a:r>
               <a:rPr sz="1050" b="1" i="0" spc="120">
                 <a:solidFill>
-                  <a:srgbClr val="CCFBF1"/>
+                  <a:srgbClr val="D8C9F5"/>
                 </a:solidFill>
                 <a:latin typeface="Consolas"/>
               </a:rPr>
@@ -14735,7 +15900,7 @@
             <a:r>
               <a:rPr sz="1200" b="0" i="0">
                 <a:solidFill>
-                  <a:srgbClr val="CCFBF1"/>
+                  <a:srgbClr val="D8C9F5"/>
                 </a:solidFill>
                 <a:latin typeface="Montserrat"/>
               </a:rPr>

</xml_diff>

<commit_message>
Add Infosys brand-coloured deck variant
- Add theme system to deck.py (THEMES: 'aerchain' purple, 'infosys' blue)
- New Unilever_Aerchain_Infosys-Brand_Deck.pptx re-skinned in the Infosys
  palette (primary #005EEF, indigo #1F36C7) pulled from the Infosys deck theme
- Generate blue agent-icon variants; add infosys_slide previews
- Original purple deck preserved unchanged

https://claude.ai/code/session_01H7Uxv6jiq6mA6LdW8qoYWz
</commit_message>
<xml_diff>
--- a/unilever-aerchain/Unilever_Aerchain_Infosys_Deck.pptx
+++ b/unilever-aerchain/Unilever_Aerchain_Infosys_Deck.pptx
@@ -8520,7 +8520,7 @@
             </a:avLst>
           </a:prstGeom>
           <a:solidFill>
-            <a:srgbClr val="ECE3FF"/>
+            <a:srgbClr val="F1EAFC"/>
           </a:solidFill>
           <a:ln>
             <a:noFill/>
@@ -9183,7 +9183,7 @@
             </a:avLst>
           </a:prstGeom>
           <a:solidFill>
-            <a:srgbClr val="ECE3FF"/>
+            <a:srgbClr val="F1EAFC"/>
           </a:solidFill>
           <a:ln>
             <a:noFill/>
@@ -9846,7 +9846,7 @@
             </a:avLst>
           </a:prstGeom>
           <a:solidFill>
-            <a:srgbClr val="ECE3FF"/>
+            <a:srgbClr val="F1EAFC"/>
           </a:solidFill>
           <a:ln>
             <a:noFill/>
@@ -10509,7 +10509,7 @@
             </a:avLst>
           </a:prstGeom>
           <a:solidFill>
-            <a:srgbClr val="ECE3FF"/>
+            <a:srgbClr val="F1EAFC"/>
           </a:solidFill>
           <a:ln>
             <a:noFill/>
@@ -11172,7 +11172,7 @@
             </a:avLst>
           </a:prstGeom>
           <a:solidFill>
-            <a:srgbClr val="ECE3FF"/>
+            <a:srgbClr val="F1EAFC"/>
           </a:solidFill>
           <a:ln>
             <a:noFill/>

</xml_diff>